<commit_message>
Updated the 3KHZ spectrum and bins - UI and CODE
Co-authored-by: Copilot <copilot@github.com>
</commit_message>
<xml_diff>
--- a/assets/Presentation.pptx
+++ b/assets/Presentation.pptx
@@ -8,6 +8,7 @@
     <p:sldId id="256" r:id="rId2"/>
     <p:sldId id="257" r:id="rId3"/>
     <p:sldId id="258" r:id="rId4"/>
+    <p:sldId id="260" r:id="rId5"/>
   </p:sldIdLst>
   <p:sldSz cx="12192000" cy="6858000"/>
   <p:notesSz cx="6858000" cy="9144000"/>
@@ -106,13 +107,18 @@
       </a:defRPr>
     </a:lvl9pPr>
   </p:defaultTextStyle>
+  <p:extLst>
+    <p:ext uri="{EFAFB233-063F-42B5-8137-9DF3F51BA10A}">
+      <p15:sldGuideLst xmlns:p15="http://schemas.microsoft.com/office/powerpoint/2012/main"/>
+    </p:ext>
+  </p:extLst>
 </p:presentation>
 </file>
 
 <file path=ppt/revisionInfo.xml><?xml version="1.0" encoding="utf-8"?>
 <p1510:revInfo xmlns:a="http://schemas.openxmlformats.org/drawingml/2006/main" xmlns:r="http://schemas.openxmlformats.org/officeDocument/2006/relationships" xmlns:p1510="http://schemas.microsoft.com/office/powerpoint/2015/10/main">
   <p1510:revLst>
-    <p1510:client id="{76BF85E1-F36E-4FDC-BAF8-1A07666A0FEF}" v="1293" dt="2026-05-01T12:15:29.312"/>
+    <p1510:client id="{76BF85E1-F36E-4FDC-BAF8-1A07666A0FEF}" v="2692" dt="2026-05-03T09:08:38.608"/>
   </p1510:revLst>
 </p1510:revInfo>
 </file>
@@ -121,13 +127,13 @@
 <pc:chgInfo xmlns:a="http://schemas.openxmlformats.org/drawingml/2006/main" xmlns:r="http://schemas.openxmlformats.org/officeDocument/2006/relationships" xmlns:ac="http://schemas.microsoft.com/office/drawing/2013/main/command" xmlns:pc="http://schemas.microsoft.com/office/powerpoint/2013/main/command">
   <pc:docChgLst>
     <pc:chgData name="Ziv Abraham" userId="c4913433ebff2b9d" providerId="LiveId" clId="{3DCE9E76-4607-4482-828F-6A8054342288}"/>
-    <pc:docChg chg="undo custSel addSld delSld modSld">
-      <pc:chgData name="Ziv Abraham" userId="c4913433ebff2b9d" providerId="LiveId" clId="{3DCE9E76-4607-4482-828F-6A8054342288}" dt="2026-05-01T12:15:29.312" v="2773" actId="20577"/>
+    <pc:docChg chg="undo custSel addSld delSld modSld modMainMaster">
+      <pc:chgData name="Ziv Abraham" userId="c4913433ebff2b9d" providerId="LiveId" clId="{3DCE9E76-4607-4482-828F-6A8054342288}" dt="2026-05-03T09:08:49.006" v="5055" actId="14100"/>
       <pc:docMkLst>
         <pc:docMk/>
       </pc:docMkLst>
       <pc:sldChg chg="addSp modSp mod setBg">
-        <pc:chgData name="Ziv Abraham" userId="c4913433ebff2b9d" providerId="LiveId" clId="{3DCE9E76-4607-4482-828F-6A8054342288}" dt="2026-05-01T11:51:25.715" v="614" actId="20577"/>
+        <pc:chgData name="Ziv Abraham" userId="c4913433ebff2b9d" providerId="LiveId" clId="{3DCE9E76-4607-4482-828F-6A8054342288}" dt="2026-05-03T07:45:30.176" v="2821"/>
         <pc:sldMkLst>
           <pc:docMk/>
           <pc:sldMk cId="1517884398" sldId="256"/>
@@ -182,37 +188,13 @@
         </pc:cxnChg>
       </pc:sldChg>
       <pc:sldChg chg="addSp delSp modSp add mod setBg">
-        <pc:chgData name="Ziv Abraham" userId="c4913433ebff2b9d" providerId="LiveId" clId="{3DCE9E76-4607-4482-828F-6A8054342288}" dt="2026-05-01T12:15:03.300" v="2766"/>
+        <pc:chgData name="Ziv Abraham" userId="c4913433ebff2b9d" providerId="LiveId" clId="{3DCE9E76-4607-4482-828F-6A8054342288}" dt="2026-05-03T09:06:06.850" v="4908" actId="27636"/>
         <pc:sldMkLst>
           <pc:docMk/>
           <pc:sldMk cId="258052296" sldId="257"/>
         </pc:sldMkLst>
-        <pc:spChg chg="del">
-          <ac:chgData name="Ziv Abraham" userId="c4913433ebff2b9d" providerId="LiveId" clId="{3DCE9E76-4607-4482-828F-6A8054342288}" dt="2026-05-01T10:53:45.801" v="79" actId="478"/>
-          <ac:spMkLst>
-            <pc:docMk/>
-            <pc:sldMk cId="258052296" sldId="257"/>
-            <ac:spMk id="2" creationId="{ABBD5D82-5F73-02EF-34EC-14BBD55EC1A3}"/>
-          </ac:spMkLst>
-        </pc:spChg>
-        <pc:spChg chg="del">
-          <ac:chgData name="Ziv Abraham" userId="c4913433ebff2b9d" providerId="LiveId" clId="{3DCE9E76-4607-4482-828F-6A8054342288}" dt="2026-05-01T10:53:44.311" v="78" actId="478"/>
-          <ac:spMkLst>
-            <pc:docMk/>
-            <pc:sldMk cId="258052296" sldId="257"/>
-            <ac:spMk id="3" creationId="{2C04DC6F-A62B-D755-D40C-0AEC4A0976EF}"/>
-          </ac:spMkLst>
-        </pc:spChg>
-        <pc:spChg chg="add del mod">
-          <ac:chgData name="Ziv Abraham" userId="c4913433ebff2b9d" providerId="LiveId" clId="{3DCE9E76-4607-4482-828F-6A8054342288}" dt="2026-05-01T10:53:50.828" v="84" actId="478"/>
-          <ac:spMkLst>
-            <pc:docMk/>
-            <pc:sldMk cId="258052296" sldId="257"/>
-            <ac:spMk id="5" creationId="{D6DC1C85-CA41-672F-2F2C-88AAC16B744D}"/>
-          </ac:spMkLst>
-        </pc:spChg>
         <pc:spChg chg="add del mod ord">
-          <ac:chgData name="Ziv Abraham" userId="c4913433ebff2b9d" providerId="LiveId" clId="{3DCE9E76-4607-4482-828F-6A8054342288}" dt="2026-05-01T11:28:32.021" v="548" actId="26606"/>
+          <ac:chgData name="Ziv Abraham" userId="c4913433ebff2b9d" providerId="LiveId" clId="{3DCE9E76-4607-4482-828F-6A8054342288}" dt="2026-05-03T08:54:37.735" v="4623" actId="14100"/>
           <ac:spMkLst>
             <pc:docMk/>
             <pc:sldMk cId="258052296" sldId="257"/>
@@ -220,211 +202,11 @@
           </ac:spMkLst>
         </pc:spChg>
         <pc:spChg chg="add mod">
-          <ac:chgData name="Ziv Abraham" userId="c4913433ebff2b9d" providerId="LiveId" clId="{3DCE9E76-4607-4482-828F-6A8054342288}" dt="2026-05-01T11:28:32.021" v="548" actId="26606"/>
+          <ac:chgData name="Ziv Abraham" userId="c4913433ebff2b9d" providerId="LiveId" clId="{3DCE9E76-4607-4482-828F-6A8054342288}" dt="2026-05-03T09:06:06.850" v="4908" actId="27636"/>
           <ac:spMkLst>
             <pc:docMk/>
             <pc:sldMk cId="258052296" sldId="257"/>
             <ac:spMk id="12" creationId="{025755C4-A103-A728-5FF4-1FAEAD92363B}"/>
-          </ac:spMkLst>
-        </pc:spChg>
-        <pc:spChg chg="add del">
-          <ac:chgData name="Ziv Abraham" userId="c4913433ebff2b9d" providerId="LiveId" clId="{3DCE9E76-4607-4482-828F-6A8054342288}" dt="2026-05-01T11:28:14.945" v="534" actId="26606"/>
-          <ac:spMkLst>
-            <pc:docMk/>
-            <pc:sldMk cId="258052296" sldId="257"/>
-            <ac:spMk id="17" creationId="{2B97F24A-32CE-4C1C-A50D-3016B394DCFB}"/>
-          </ac:spMkLst>
-        </pc:spChg>
-        <pc:spChg chg="add del">
-          <ac:chgData name="Ziv Abraham" userId="c4913433ebff2b9d" providerId="LiveId" clId="{3DCE9E76-4607-4482-828F-6A8054342288}" dt="2026-05-01T11:28:14.945" v="534" actId="26606"/>
-          <ac:spMkLst>
-            <pc:docMk/>
-            <pc:sldMk cId="258052296" sldId="257"/>
-            <ac:spMk id="19" creationId="{CD8B4F24-440B-49E9-B85D-733523DC064B}"/>
-          </ac:spMkLst>
-        </pc:spChg>
-        <pc:spChg chg="add del">
-          <ac:chgData name="Ziv Abraham" userId="c4913433ebff2b9d" providerId="LiveId" clId="{3DCE9E76-4607-4482-828F-6A8054342288}" dt="2026-05-01T11:28:16.716" v="536" actId="26606"/>
-          <ac:spMkLst>
-            <pc:docMk/>
-            <pc:sldMk cId="258052296" sldId="257"/>
-            <ac:spMk id="21" creationId="{55222F96-971A-4F90-B841-6BAB416C7AC1}"/>
-          </ac:spMkLst>
-        </pc:spChg>
-        <pc:spChg chg="add del">
-          <ac:chgData name="Ziv Abraham" userId="c4913433ebff2b9d" providerId="LiveId" clId="{3DCE9E76-4607-4482-828F-6A8054342288}" dt="2026-05-01T11:28:16.716" v="536" actId="26606"/>
-          <ac:spMkLst>
-            <pc:docMk/>
-            <pc:sldMk cId="258052296" sldId="257"/>
-            <ac:spMk id="22" creationId="{DBC6133C-0615-4CE4-9132-37E609A9BDFA}"/>
-          </ac:spMkLst>
-        </pc:spChg>
-        <pc:spChg chg="add del">
-          <ac:chgData name="Ziv Abraham" userId="c4913433ebff2b9d" providerId="LiveId" clId="{3DCE9E76-4607-4482-828F-6A8054342288}" dt="2026-05-01T11:28:16.716" v="536" actId="26606"/>
-          <ac:spMkLst>
-            <pc:docMk/>
-            <pc:sldMk cId="258052296" sldId="257"/>
-            <ac:spMk id="23" creationId="{08980754-6F4B-43C9-B9BE-127B6BED6586}"/>
-          </ac:spMkLst>
-        </pc:spChg>
-        <pc:spChg chg="add del">
-          <ac:chgData name="Ziv Abraham" userId="c4913433ebff2b9d" providerId="LiveId" clId="{3DCE9E76-4607-4482-828F-6A8054342288}" dt="2026-05-01T11:28:16.716" v="536" actId="26606"/>
-          <ac:spMkLst>
-            <pc:docMk/>
-            <pc:sldMk cId="258052296" sldId="257"/>
-            <ac:spMk id="24" creationId="{169CC832-2974-4E8D-90ED-3E2941BA7336}"/>
-          </ac:spMkLst>
-        </pc:spChg>
-        <pc:spChg chg="add del">
-          <ac:chgData name="Ziv Abraham" userId="c4913433ebff2b9d" providerId="LiveId" clId="{3DCE9E76-4607-4482-828F-6A8054342288}" dt="2026-05-01T11:28:16.716" v="536" actId="26606"/>
-          <ac:spMkLst>
-            <pc:docMk/>
-            <pc:sldMk cId="258052296" sldId="257"/>
-            <ac:spMk id="25" creationId="{2C1BBA94-3F40-40AA-8BB9-E69E25E537C1}"/>
-          </ac:spMkLst>
-        </pc:spChg>
-        <pc:spChg chg="add del">
-          <ac:chgData name="Ziv Abraham" userId="c4913433ebff2b9d" providerId="LiveId" clId="{3DCE9E76-4607-4482-828F-6A8054342288}" dt="2026-05-01T11:28:17.214" v="538" actId="26606"/>
-          <ac:spMkLst>
-            <pc:docMk/>
-            <pc:sldMk cId="258052296" sldId="257"/>
-            <ac:spMk id="27" creationId="{2B97F24A-32CE-4C1C-A50D-3016B394DCFB}"/>
-          </ac:spMkLst>
-        </pc:spChg>
-        <pc:spChg chg="add del">
-          <ac:chgData name="Ziv Abraham" userId="c4913433ebff2b9d" providerId="LiveId" clId="{3DCE9E76-4607-4482-828F-6A8054342288}" dt="2026-05-01T11:28:17.214" v="538" actId="26606"/>
-          <ac:spMkLst>
-            <pc:docMk/>
-            <pc:sldMk cId="258052296" sldId="257"/>
-            <ac:spMk id="28" creationId="{6357EC4F-235E-4222-A36F-C7878ACE37F2}"/>
-          </ac:spMkLst>
-        </pc:spChg>
-        <pc:spChg chg="add del">
-          <ac:chgData name="Ziv Abraham" userId="c4913433ebff2b9d" providerId="LiveId" clId="{3DCE9E76-4607-4482-828F-6A8054342288}" dt="2026-05-01T11:28:20.596" v="540" actId="26606"/>
-          <ac:spMkLst>
-            <pc:docMk/>
-            <pc:sldMk cId="258052296" sldId="257"/>
-            <ac:spMk id="30" creationId="{21A75659-5A6F-4F77-9679-678A00B9D8DC}"/>
-          </ac:spMkLst>
-        </pc:spChg>
-        <pc:spChg chg="add del">
-          <ac:chgData name="Ziv Abraham" userId="c4913433ebff2b9d" providerId="LiveId" clId="{3DCE9E76-4607-4482-828F-6A8054342288}" dt="2026-05-01T11:28:20.596" v="540" actId="26606"/>
-          <ac:spMkLst>
-            <pc:docMk/>
-            <pc:sldMk cId="258052296" sldId="257"/>
-            <ac:spMk id="31" creationId="{E30A3A45-140E-431E-AED0-07EF836310B3}"/>
-          </ac:spMkLst>
-        </pc:spChg>
-        <pc:spChg chg="add del">
-          <ac:chgData name="Ziv Abraham" userId="c4913433ebff2b9d" providerId="LiveId" clId="{3DCE9E76-4607-4482-828F-6A8054342288}" dt="2026-05-01T11:28:20.596" v="540" actId="26606"/>
-          <ac:spMkLst>
-            <pc:docMk/>
-            <pc:sldMk cId="258052296" sldId="257"/>
-            <ac:spMk id="32" creationId="{55D4142C-5077-457F-A6AD-3FECFDB39685}"/>
-          </ac:spMkLst>
-        </pc:spChg>
-        <pc:spChg chg="add del">
-          <ac:chgData name="Ziv Abraham" userId="c4913433ebff2b9d" providerId="LiveId" clId="{3DCE9E76-4607-4482-828F-6A8054342288}" dt="2026-05-01T11:28:20.596" v="540" actId="26606"/>
-          <ac:spMkLst>
-            <pc:docMk/>
-            <pc:sldMk cId="258052296" sldId="257"/>
-            <ac:spMk id="33" creationId="{7A5F0580-5EE9-419F-96EE-B6529EF6E7D0}"/>
-          </ac:spMkLst>
-        </pc:spChg>
-        <pc:spChg chg="add del">
-          <ac:chgData name="Ziv Abraham" userId="c4913433ebff2b9d" providerId="LiveId" clId="{3DCE9E76-4607-4482-828F-6A8054342288}" dt="2026-05-01T11:28:22.805" v="543" actId="26606"/>
-          <ac:spMkLst>
-            <pc:docMk/>
-            <pc:sldMk cId="258052296" sldId="257"/>
-            <ac:spMk id="35" creationId="{5DCB5928-DC7D-4612-9922-441966E15627}"/>
-          </ac:spMkLst>
-        </pc:spChg>
-        <pc:spChg chg="add del">
-          <ac:chgData name="Ziv Abraham" userId="c4913433ebff2b9d" providerId="LiveId" clId="{3DCE9E76-4607-4482-828F-6A8054342288}" dt="2026-05-01T11:28:22.805" v="543" actId="26606"/>
-          <ac:spMkLst>
-            <pc:docMk/>
-            <pc:sldMk cId="258052296" sldId="257"/>
-            <ac:spMk id="36" creationId="{682C1161-1736-45EC-99B7-33F3CAE9D517}"/>
-          </ac:spMkLst>
-        </pc:spChg>
-        <pc:spChg chg="add del">
-          <ac:chgData name="Ziv Abraham" userId="c4913433ebff2b9d" providerId="LiveId" clId="{3DCE9E76-4607-4482-828F-6A8054342288}" dt="2026-05-01T11:28:22.805" v="543" actId="26606"/>
-          <ac:spMkLst>
-            <pc:docMk/>
-            <pc:sldMk cId="258052296" sldId="257"/>
-            <ac:spMk id="37" creationId="{84D4DDB8-B68F-45B0-9F62-C4279996F672}"/>
-          </ac:spMkLst>
-        </pc:spChg>
-        <pc:spChg chg="add del">
-          <ac:chgData name="Ziv Abraham" userId="c4913433ebff2b9d" providerId="LiveId" clId="{3DCE9E76-4607-4482-828F-6A8054342288}" dt="2026-05-01T11:28:22.805" v="543" actId="26606"/>
-          <ac:spMkLst>
-            <pc:docMk/>
-            <pc:sldMk cId="258052296" sldId="257"/>
-            <ac:spMk id="38" creationId="{AF2F604E-43BE-4DC3-B983-E071523364F8}"/>
-          </ac:spMkLst>
-        </pc:spChg>
-        <pc:spChg chg="add del">
-          <ac:chgData name="Ziv Abraham" userId="c4913433ebff2b9d" providerId="LiveId" clId="{3DCE9E76-4607-4482-828F-6A8054342288}" dt="2026-05-01T11:28:22.805" v="543" actId="26606"/>
-          <ac:spMkLst>
-            <pc:docMk/>
-            <pc:sldMk cId="258052296" sldId="257"/>
-            <ac:spMk id="39" creationId="{08C9B587-E65E-4B52-B37C-ABEBB6E87928}"/>
-          </ac:spMkLst>
-        </pc:spChg>
-        <pc:spChg chg="add del">
-          <ac:chgData name="Ziv Abraham" userId="c4913433ebff2b9d" providerId="LiveId" clId="{3DCE9E76-4607-4482-828F-6A8054342288}" dt="2026-05-01T11:28:28.714" v="545" actId="26606"/>
-          <ac:spMkLst>
-            <pc:docMk/>
-            <pc:sldMk cId="258052296" sldId="257"/>
-            <ac:spMk id="41" creationId="{DBC6133C-0615-4CE4-9132-37E609A9BDFA}"/>
-          </ac:spMkLst>
-        </pc:spChg>
-        <pc:spChg chg="add del">
-          <ac:chgData name="Ziv Abraham" userId="c4913433ebff2b9d" providerId="LiveId" clId="{3DCE9E76-4607-4482-828F-6A8054342288}" dt="2026-05-01T11:28:28.714" v="545" actId="26606"/>
-          <ac:spMkLst>
-            <pc:docMk/>
-            <pc:sldMk cId="258052296" sldId="257"/>
-            <ac:spMk id="42" creationId="{169CC832-2974-4E8D-90ED-3E2941BA7336}"/>
-          </ac:spMkLst>
-        </pc:spChg>
-        <pc:spChg chg="add del">
-          <ac:chgData name="Ziv Abraham" userId="c4913433ebff2b9d" providerId="LiveId" clId="{3DCE9E76-4607-4482-828F-6A8054342288}" dt="2026-05-01T11:28:28.714" v="545" actId="26606"/>
-          <ac:spMkLst>
-            <pc:docMk/>
-            <pc:sldMk cId="258052296" sldId="257"/>
-            <ac:spMk id="43" creationId="{55222F96-971A-4F90-B841-6BAB416C7AC1}"/>
-          </ac:spMkLst>
-        </pc:spChg>
-        <pc:spChg chg="add del">
-          <ac:chgData name="Ziv Abraham" userId="c4913433ebff2b9d" providerId="LiveId" clId="{3DCE9E76-4607-4482-828F-6A8054342288}" dt="2026-05-01T11:28:28.714" v="545" actId="26606"/>
-          <ac:spMkLst>
-            <pc:docMk/>
-            <pc:sldMk cId="258052296" sldId="257"/>
-            <ac:spMk id="44" creationId="{08980754-6F4B-43C9-B9BE-127B6BED6586}"/>
-          </ac:spMkLst>
-        </pc:spChg>
-        <pc:spChg chg="add del">
-          <ac:chgData name="Ziv Abraham" userId="c4913433ebff2b9d" providerId="LiveId" clId="{3DCE9E76-4607-4482-828F-6A8054342288}" dt="2026-05-01T11:28:28.714" v="545" actId="26606"/>
-          <ac:spMkLst>
-            <pc:docMk/>
-            <pc:sldMk cId="258052296" sldId="257"/>
-            <ac:spMk id="45" creationId="{2C1BBA94-3F40-40AA-8BB9-E69E25E537C1}"/>
-          </ac:spMkLst>
-        </pc:spChg>
-        <pc:spChg chg="add del">
-          <ac:chgData name="Ziv Abraham" userId="c4913433ebff2b9d" providerId="LiveId" clId="{3DCE9E76-4607-4482-828F-6A8054342288}" dt="2026-05-01T11:28:32.015" v="547" actId="26606"/>
-          <ac:spMkLst>
-            <pc:docMk/>
-            <pc:sldMk cId="258052296" sldId="257"/>
-            <ac:spMk id="47" creationId="{2B97F24A-32CE-4C1C-A50D-3016B394DCFB}"/>
-          </ac:spMkLst>
-        </pc:spChg>
-        <pc:spChg chg="add del">
-          <ac:chgData name="Ziv Abraham" userId="c4913433ebff2b9d" providerId="LiveId" clId="{3DCE9E76-4607-4482-828F-6A8054342288}" dt="2026-05-01T11:28:32.015" v="547" actId="26606"/>
-          <ac:spMkLst>
-            <pc:docMk/>
-            <pc:sldMk cId="258052296" sldId="257"/>
-            <ac:spMk id="48" creationId="{CD8B4F24-440B-49E9-B85D-733523DC064B}"/>
           </ac:spMkLst>
         </pc:spChg>
         <pc:spChg chg="add">
@@ -467,14 +249,6 @@
             <ac:spMk id="54" creationId="{2C1BBA94-3F40-40AA-8BB9-E69E25E537C1}"/>
           </ac:spMkLst>
         </pc:spChg>
-        <pc:picChg chg="add del mod">
-          <ac:chgData name="Ziv Abraham" userId="c4913433ebff2b9d" providerId="LiveId" clId="{3DCE9E76-4607-4482-828F-6A8054342288}" dt="2026-05-01T11:20:28.732" v="125" actId="478"/>
-          <ac:picMkLst>
-            <pc:docMk/>
-            <pc:sldMk cId="258052296" sldId="257"/>
-            <ac:picMk id="9" creationId="{536FEB4B-36CC-E86A-29BE-762D32BEB322}"/>
-          </ac:picMkLst>
-        </pc:picChg>
         <pc:picChg chg="add mod ord">
           <ac:chgData name="Ziv Abraham" userId="c4913433ebff2b9d" providerId="LiveId" clId="{3DCE9E76-4607-4482-828F-6A8054342288}" dt="2026-05-01T11:28:32.021" v="548" actId="26606"/>
           <ac:picMkLst>
@@ -484,28 +258,14 @@
           </ac:picMkLst>
         </pc:picChg>
       </pc:sldChg>
-      <pc:sldChg chg="add del setBg">
-        <pc:chgData name="Ziv Abraham" userId="c4913433ebff2b9d" providerId="LiveId" clId="{3DCE9E76-4607-4482-828F-6A8054342288}" dt="2026-05-01T11:26:48.317" v="482"/>
-        <pc:sldMkLst>
-          <pc:docMk/>
-          <pc:sldMk cId="162152955" sldId="258"/>
-        </pc:sldMkLst>
-      </pc:sldChg>
-      <pc:sldChg chg="new del">
-        <pc:chgData name="Ziv Abraham" userId="c4913433ebff2b9d" providerId="LiveId" clId="{3DCE9E76-4607-4482-828F-6A8054342288}" dt="2026-05-01T11:26:44.772" v="480" actId="47"/>
-        <pc:sldMkLst>
-          <pc:docMk/>
-          <pc:sldMk cId="821112053" sldId="258"/>
-        </pc:sldMkLst>
-      </pc:sldChg>
       <pc:sldChg chg="addSp delSp modSp add mod setBg">
-        <pc:chgData name="Ziv Abraham" userId="c4913433ebff2b9d" providerId="LiveId" clId="{3DCE9E76-4607-4482-828F-6A8054342288}" dt="2026-05-01T12:15:29.312" v="2773" actId="20577"/>
+        <pc:chgData name="Ziv Abraham" userId="c4913433ebff2b9d" providerId="LiveId" clId="{3DCE9E76-4607-4482-828F-6A8054342288}" dt="2026-05-03T08:54:57.289" v="4626" actId="2711"/>
         <pc:sldMkLst>
           <pc:docMk/>
           <pc:sldMk cId="1512192545" sldId="258"/>
         </pc:sldMkLst>
         <pc:spChg chg="add mod">
-          <ac:chgData name="Ziv Abraham" userId="c4913433ebff2b9d" providerId="LiveId" clId="{3DCE9E76-4607-4482-828F-6A8054342288}" dt="2026-05-01T12:13:23.358" v="2723" actId="20577"/>
+          <ac:chgData name="Ziv Abraham" userId="c4913433ebff2b9d" providerId="LiveId" clId="{3DCE9E76-4607-4482-828F-6A8054342288}" dt="2026-05-03T08:54:57.289" v="4626" actId="2711"/>
           <ac:spMkLst>
             <pc:docMk/>
             <pc:sldMk cId="1512192545" sldId="258"/>
@@ -513,7 +273,7 @@
           </ac:spMkLst>
         </pc:spChg>
         <pc:spChg chg="mod">
-          <ac:chgData name="Ziv Abraham" userId="c4913433ebff2b9d" providerId="LiveId" clId="{3DCE9E76-4607-4482-828F-6A8054342288}" dt="2026-05-01T11:27:11.640" v="529" actId="20577"/>
+          <ac:chgData name="Ziv Abraham" userId="c4913433ebff2b9d" providerId="LiveId" clId="{3DCE9E76-4607-4482-828F-6A8054342288}" dt="2026-05-03T08:54:45.279" v="4625" actId="108"/>
           <ac:spMkLst>
             <pc:docMk/>
             <pc:sldMk cId="1512192545" sldId="258"/>
@@ -521,7 +281,7 @@
           </ac:spMkLst>
         </pc:spChg>
         <pc:spChg chg="mod">
-          <ac:chgData name="Ziv Abraham" userId="c4913433ebff2b9d" providerId="LiveId" clId="{3DCE9E76-4607-4482-828F-6A8054342288}" dt="2026-05-01T12:03:36.853" v="2029" actId="20577"/>
+          <ac:chgData name="Ziv Abraham" userId="c4913433ebff2b9d" providerId="LiveId" clId="{3DCE9E76-4607-4482-828F-6A8054342288}" dt="2026-05-03T08:54:57.289" v="4626" actId="2711"/>
           <ac:spMkLst>
             <pc:docMk/>
             <pc:sldMk cId="1512192545" sldId="258"/>
@@ -529,204 +289,163 @@
           </ac:spMkLst>
         </pc:spChg>
         <pc:graphicFrameChg chg="add mod modGraphic">
-          <ac:chgData name="Ziv Abraham" userId="c4913433ebff2b9d" providerId="LiveId" clId="{3DCE9E76-4607-4482-828F-6A8054342288}" dt="2026-05-01T12:15:29.312" v="2773" actId="20577"/>
+          <ac:chgData name="Ziv Abraham" userId="c4913433ebff2b9d" providerId="LiveId" clId="{3DCE9E76-4607-4482-828F-6A8054342288}" dt="2026-05-03T08:54:57.289" v="4626" actId="2711"/>
           <ac:graphicFrameMkLst>
             <pc:docMk/>
             <pc:sldMk cId="1512192545" sldId="258"/>
             <ac:graphicFrameMk id="2" creationId="{D5FE1567-6450-8FE7-CD32-90216FA63996}"/>
           </ac:graphicFrameMkLst>
         </pc:graphicFrameChg>
-        <pc:picChg chg="del">
-          <ac:chgData name="Ziv Abraham" userId="c4913433ebff2b9d" providerId="LiveId" clId="{3DCE9E76-4607-4482-828F-6A8054342288}" dt="2026-05-01T11:27:13.795" v="530" actId="478"/>
-          <ac:picMkLst>
-            <pc:docMk/>
-            <pc:sldMk cId="1512192545" sldId="258"/>
-            <ac:picMk id="11" creationId="{60FA47F2-E9AB-FD63-8D20-83B517473CA3}"/>
-          </ac:picMkLst>
-        </pc:picChg>
       </pc:sldChg>
-      <pc:sldChg chg="delSp add del setBg delDesignElem">
-        <pc:chgData name="Ziv Abraham" userId="c4913433ebff2b9d" providerId="LiveId" clId="{3DCE9E76-4607-4482-828F-6A8054342288}" dt="2026-05-01T12:14:15.229" v="2748" actId="47"/>
+      <pc:sldChg chg="new del">
+        <pc:chgData name="Ziv Abraham" userId="c4913433ebff2b9d" providerId="LiveId" clId="{3DCE9E76-4607-4482-828F-6A8054342288}" dt="2026-05-03T07:45:15.207" v="2820" actId="47"/>
         <pc:sldMkLst>
           <pc:docMk/>
-          <pc:sldMk cId="1324364502" sldId="259"/>
+          <pc:sldMk cId="723258615" sldId="259"/>
+        </pc:sldMkLst>
+      </pc:sldChg>
+      <pc:sldChg chg="addSp delSp modSp add mod setBg">
+        <pc:chgData name="Ziv Abraham" userId="c4913433ebff2b9d" providerId="LiveId" clId="{3DCE9E76-4607-4482-828F-6A8054342288}" dt="2026-05-03T09:08:49.006" v="5055" actId="14100"/>
+        <pc:sldMkLst>
+          <pc:docMk/>
+          <pc:sldMk cId="299412291" sldId="260"/>
         </pc:sldMkLst>
         <pc:spChg chg="del">
-          <ac:chgData name="Ziv Abraham" userId="c4913433ebff2b9d" providerId="LiveId" clId="{3DCE9E76-4607-4482-828F-6A8054342288}" dt="2026-05-01T12:14:07.733" v="2746"/>
+          <ac:chgData name="Ziv Abraham" userId="c4913433ebff2b9d" providerId="LiveId" clId="{3DCE9E76-4607-4482-828F-6A8054342288}" dt="2026-05-03T08:45:29.520" v="4469" actId="478"/>
           <ac:spMkLst>
             <pc:docMk/>
-            <pc:sldMk cId="1324364502" sldId="259"/>
-            <ac:spMk id="50" creationId="{5365539B-2866-8471-D5D7-EF09320576D3}"/>
-          </ac:spMkLst>
-        </pc:spChg>
-        <pc:spChg chg="del">
-          <ac:chgData name="Ziv Abraham" userId="c4913433ebff2b9d" providerId="LiveId" clId="{3DCE9E76-4607-4482-828F-6A8054342288}" dt="2026-05-01T12:14:07.733" v="2746"/>
-          <ac:spMkLst>
-            <pc:docMk/>
-            <pc:sldMk cId="1324364502" sldId="259"/>
-            <ac:spMk id="51" creationId="{F2E33E0F-D037-9349-9CD4-0CC02514F821}"/>
-          </ac:spMkLst>
-        </pc:spChg>
-        <pc:spChg chg="del">
-          <ac:chgData name="Ziv Abraham" userId="c4913433ebff2b9d" providerId="LiveId" clId="{3DCE9E76-4607-4482-828F-6A8054342288}" dt="2026-05-01T12:14:07.733" v="2746"/>
-          <ac:spMkLst>
-            <pc:docMk/>
-            <pc:sldMk cId="1324364502" sldId="259"/>
-            <ac:spMk id="52" creationId="{F76992CC-267B-F404-8BE0-12A55496272D}"/>
-          </ac:spMkLst>
-        </pc:spChg>
-        <pc:spChg chg="del">
-          <ac:chgData name="Ziv Abraham" userId="c4913433ebff2b9d" providerId="LiveId" clId="{3DCE9E76-4607-4482-828F-6A8054342288}" dt="2026-05-01T12:14:07.733" v="2746"/>
-          <ac:spMkLst>
-            <pc:docMk/>
-            <pc:sldMk cId="1324364502" sldId="259"/>
-            <ac:spMk id="53" creationId="{6C5BDD5C-C2F0-7606-DF56-3A8B49ADD5C6}"/>
-          </ac:spMkLst>
-        </pc:spChg>
-        <pc:spChg chg="del">
-          <ac:chgData name="Ziv Abraham" userId="c4913433ebff2b9d" providerId="LiveId" clId="{3DCE9E76-4607-4482-828F-6A8054342288}" dt="2026-05-01T12:14:07.733" v="2746"/>
-          <ac:spMkLst>
-            <pc:docMk/>
-            <pc:sldMk cId="1324364502" sldId="259"/>
-            <ac:spMk id="54" creationId="{8CADB4FC-4832-857A-6FEE-08947CD2F3CF}"/>
-          </ac:spMkLst>
-        </pc:spChg>
-      </pc:sldChg>
-      <pc:sldChg chg="addSp delSp modSp add del mod">
-        <pc:chgData name="Ziv Abraham" userId="c4913433ebff2b9d" providerId="LiveId" clId="{3DCE9E76-4607-4482-828F-6A8054342288}" dt="2026-05-01T12:14:38.534" v="2758" actId="47"/>
-        <pc:sldMkLst>
-          <pc:docMk/>
-          <pc:sldMk cId="434488389" sldId="260"/>
-        </pc:sldMkLst>
-        <pc:spChg chg="add del mod">
-          <ac:chgData name="Ziv Abraham" userId="c4913433ebff2b9d" providerId="LiveId" clId="{3DCE9E76-4607-4482-828F-6A8054342288}" dt="2026-05-01T12:14:19.317" v="2750" actId="478"/>
-          <ac:spMkLst>
-            <pc:docMk/>
-            <pc:sldMk cId="434488389" sldId="260"/>
-            <ac:spMk id="3" creationId="{87D2F014-C9AB-108A-B3C5-A6128B0BE977}"/>
+            <pc:sldMk cId="299412291" sldId="260"/>
+            <ac:spMk id="3" creationId="{BDE4D6A9-5A7F-4CEC-F157-6344BA9825F6}"/>
           </ac:spMkLst>
         </pc:spChg>
         <pc:spChg chg="add del mod">
-          <ac:chgData name="Ziv Abraham" userId="c4913433ebff2b9d" providerId="LiveId" clId="{3DCE9E76-4607-4482-828F-6A8054342288}" dt="2026-05-01T12:14:19.317" v="2750" actId="478"/>
+          <ac:chgData name="Ziv Abraham" userId="c4913433ebff2b9d" providerId="LiveId" clId="{3DCE9E76-4607-4482-828F-6A8054342288}" dt="2026-05-03T07:53:35.026" v="3597" actId="478"/>
           <ac:spMkLst>
             <pc:docMk/>
-            <pc:sldMk cId="434488389" sldId="260"/>
-            <ac:spMk id="5" creationId="{01023C7C-6376-6504-2673-178F0E0394B9}"/>
+            <pc:sldMk cId="299412291" sldId="260"/>
+            <ac:spMk id="5" creationId="{EF4841FF-B2FC-9020-886C-9D29147E9912}"/>
           </ac:spMkLst>
         </pc:spChg>
-        <pc:spChg chg="add del">
-          <ac:chgData name="Ziv Abraham" userId="c4913433ebff2b9d" providerId="LiveId" clId="{3DCE9E76-4607-4482-828F-6A8054342288}" dt="2026-05-01T12:14:24.143" v="2753" actId="478"/>
+        <pc:spChg chg="mod">
+          <ac:chgData name="Ziv Abraham" userId="c4913433ebff2b9d" providerId="LiveId" clId="{3DCE9E76-4607-4482-828F-6A8054342288}" dt="2026-05-03T08:54:40.365" v="4624" actId="108"/>
           <ac:spMkLst>
             <pc:docMk/>
-            <pc:sldMk cId="434488389" sldId="260"/>
-            <ac:spMk id="7" creationId="{0D6B8628-B0EE-51C0-B772-10DDDE696F28}"/>
+            <pc:sldMk cId="299412291" sldId="260"/>
+            <ac:spMk id="7" creationId="{C10BFB91-FED0-D611-213E-1CE17DE9425D}"/>
           </ac:spMkLst>
         </pc:spChg>
         <pc:spChg chg="add del mod">
-          <ac:chgData name="Ziv Abraham" userId="c4913433ebff2b9d" providerId="LiveId" clId="{3DCE9E76-4607-4482-828F-6A8054342288}" dt="2026-05-01T12:14:37.410" v="2757" actId="478"/>
+          <ac:chgData name="Ziv Abraham" userId="c4913433ebff2b9d" providerId="LiveId" clId="{3DCE9E76-4607-4482-828F-6A8054342288}" dt="2026-05-03T09:08:49.006" v="5055" actId="14100"/>
           <ac:spMkLst>
             <pc:docMk/>
-            <pc:sldMk cId="434488389" sldId="260"/>
-            <ac:spMk id="8" creationId="{8AE5F262-2C29-A07D-8102-7B34EF8B9E9E}"/>
+            <pc:sldMk cId="299412291" sldId="260"/>
+            <ac:spMk id="12" creationId="{A7569F0F-F547-146D-68F5-9B9367B99BC6}"/>
           </ac:spMkLst>
         </pc:spChg>
-        <pc:spChg chg="add del mod">
-          <ac:chgData name="Ziv Abraham" userId="c4913433ebff2b9d" providerId="LiveId" clId="{3DCE9E76-4607-4482-828F-6A8054342288}" dt="2026-05-01T12:14:25.821" v="2754" actId="478"/>
-          <ac:spMkLst>
-            <pc:docMk/>
-            <pc:sldMk cId="434488389" sldId="260"/>
-            <ac:spMk id="10" creationId="{43C96098-7294-DED9-E010-D3B790BDDDAE}"/>
-          </ac:spMkLst>
-        </pc:spChg>
-        <pc:spChg chg="add del">
-          <ac:chgData name="Ziv Abraham" userId="c4913433ebff2b9d" providerId="LiveId" clId="{3DCE9E76-4607-4482-828F-6A8054342288}" dt="2026-05-01T12:14:22.447" v="2752" actId="478"/>
-          <ac:spMkLst>
-            <pc:docMk/>
-            <pc:sldMk cId="434488389" sldId="260"/>
-            <ac:spMk id="12" creationId="{679BA1B8-3F9D-7495-7137-8FE704B48C42}"/>
-          </ac:spMkLst>
-        </pc:spChg>
-        <pc:spChg chg="add mod">
-          <ac:chgData name="Ziv Abraham" userId="c4913433ebff2b9d" providerId="LiveId" clId="{3DCE9E76-4607-4482-828F-6A8054342288}" dt="2026-05-01T12:14:31.463" v="2756"/>
-          <ac:spMkLst>
-            <pc:docMk/>
-            <pc:sldMk cId="434488389" sldId="260"/>
-            <ac:spMk id="13" creationId="{7968835C-2C28-A688-F353-C9B8D32C5995}"/>
-          </ac:spMkLst>
-        </pc:spChg>
-        <pc:spChg chg="add mod">
-          <ac:chgData name="Ziv Abraham" userId="c4913433ebff2b9d" providerId="LiveId" clId="{3DCE9E76-4607-4482-828F-6A8054342288}" dt="2026-05-01T12:14:31.463" v="2756"/>
-          <ac:spMkLst>
-            <pc:docMk/>
-            <pc:sldMk cId="434488389" sldId="260"/>
-            <ac:spMk id="14" creationId="{C61CD302-BC27-203D-7435-A1B082671D66}"/>
-          </ac:spMkLst>
-        </pc:spChg>
-        <pc:spChg chg="add mod">
-          <ac:chgData name="Ziv Abraham" userId="c4913433ebff2b9d" providerId="LiveId" clId="{3DCE9E76-4607-4482-828F-6A8054342288}" dt="2026-05-01T12:14:31.463" v="2756"/>
-          <ac:spMkLst>
-            <pc:docMk/>
-            <pc:sldMk cId="434488389" sldId="260"/>
-            <ac:spMk id="16" creationId="{36428179-75F0-4907-692A-78E52F987A30}"/>
-          </ac:spMkLst>
-        </pc:spChg>
-        <pc:spChg chg="add del">
-          <ac:chgData name="Ziv Abraham" userId="c4913433ebff2b9d" providerId="LiveId" clId="{3DCE9E76-4607-4482-828F-6A8054342288}" dt="2026-05-01T12:14:19.317" v="2750" actId="478"/>
-          <ac:spMkLst>
-            <pc:docMk/>
-            <pc:sldMk cId="434488389" sldId="260"/>
-            <ac:spMk id="50" creationId="{B6BAE83F-6ECB-38C7-6C46-A807C9D74585}"/>
-          </ac:spMkLst>
-        </pc:spChg>
-        <pc:spChg chg="add del">
-          <ac:chgData name="Ziv Abraham" userId="c4913433ebff2b9d" providerId="LiveId" clId="{3DCE9E76-4607-4482-828F-6A8054342288}" dt="2026-05-01T12:14:19.317" v="2750" actId="478"/>
-          <ac:spMkLst>
-            <pc:docMk/>
-            <pc:sldMk cId="434488389" sldId="260"/>
-            <ac:spMk id="51" creationId="{7FEA3CFA-EDFF-F5FC-378F-54D11BE853DB}"/>
-          </ac:spMkLst>
-        </pc:spChg>
-        <pc:spChg chg="add del">
-          <ac:chgData name="Ziv Abraham" userId="c4913433ebff2b9d" providerId="LiveId" clId="{3DCE9E76-4607-4482-828F-6A8054342288}" dt="2026-05-01T12:14:19.317" v="2750" actId="478"/>
-          <ac:spMkLst>
-            <pc:docMk/>
-            <pc:sldMk cId="434488389" sldId="260"/>
-            <ac:spMk id="52" creationId="{94733645-62BE-9F20-BB79-E18D86A53E33}"/>
-          </ac:spMkLst>
-        </pc:spChg>
-        <pc:spChg chg="add del">
-          <ac:chgData name="Ziv Abraham" userId="c4913433ebff2b9d" providerId="LiveId" clId="{3DCE9E76-4607-4482-828F-6A8054342288}" dt="2026-05-01T12:14:19.317" v="2750" actId="478"/>
-          <ac:spMkLst>
-            <pc:docMk/>
-            <pc:sldMk cId="434488389" sldId="260"/>
-            <ac:spMk id="53" creationId="{D67D695F-3901-0F32-506E-FC9E026BA9D1}"/>
-          </ac:spMkLst>
-        </pc:spChg>
-        <pc:spChg chg="add del">
-          <ac:chgData name="Ziv Abraham" userId="c4913433ebff2b9d" providerId="LiveId" clId="{3DCE9E76-4607-4482-828F-6A8054342288}" dt="2026-05-01T12:14:19.317" v="2750" actId="478"/>
-          <ac:spMkLst>
-            <pc:docMk/>
-            <pc:sldMk cId="434488389" sldId="260"/>
-            <ac:spMk id="54" creationId="{C8670898-B55E-D51A-AFFD-E9FB249F1B85}"/>
-          </ac:spMkLst>
-        </pc:spChg>
-        <pc:graphicFrameChg chg="add mod">
-          <ac:chgData name="Ziv Abraham" userId="c4913433ebff2b9d" providerId="LiveId" clId="{3DCE9E76-4607-4482-828F-6A8054342288}" dt="2026-05-01T12:14:31.463" v="2756"/>
+        <pc:graphicFrameChg chg="del">
+          <ac:chgData name="Ziv Abraham" userId="c4913433ebff2b9d" providerId="LiveId" clId="{3DCE9E76-4607-4482-828F-6A8054342288}" dt="2026-05-03T08:45:28.227" v="4468" actId="478"/>
           <ac:graphicFrameMkLst>
             <pc:docMk/>
-            <pc:sldMk cId="434488389" sldId="260"/>
-            <ac:graphicFrameMk id="15" creationId="{49BCF4E3-8C34-B17C-E6BB-2134E82DF657}"/>
+            <pc:sldMk cId="299412291" sldId="260"/>
+            <ac:graphicFrameMk id="2" creationId="{C220E039-3672-54DF-048B-D03F019E4350}"/>
           </ac:graphicFrameMkLst>
         </pc:graphicFrameChg>
-        <pc:picChg chg="add del">
-          <ac:chgData name="Ziv Abraham" userId="c4913433ebff2b9d" providerId="LiveId" clId="{3DCE9E76-4607-4482-828F-6A8054342288}" dt="2026-05-01T12:14:21.694" v="2751" actId="478"/>
-          <ac:picMkLst>
+      </pc:sldChg>
+      <pc:sldMasterChg chg="setBg modSldLayout">
+        <pc:chgData name="Ziv Abraham" userId="c4913433ebff2b9d" providerId="LiveId" clId="{3DCE9E76-4607-4482-828F-6A8054342288}" dt="2026-05-03T07:45:30.176" v="2821"/>
+        <pc:sldMasterMkLst>
+          <pc:docMk/>
+          <pc:sldMasterMk cId="3373909067" sldId="2147483648"/>
+        </pc:sldMasterMkLst>
+        <pc:sldLayoutChg chg="setBg">
+          <pc:chgData name="Ziv Abraham" userId="c4913433ebff2b9d" providerId="LiveId" clId="{3DCE9E76-4607-4482-828F-6A8054342288}" dt="2026-05-03T07:45:30.176" v="2821"/>
+          <pc:sldLayoutMkLst>
             <pc:docMk/>
-            <pc:sldMk cId="434488389" sldId="260"/>
-            <ac:picMk id="11" creationId="{4F5E9020-E2DB-A39D-DD56-5439554853F9}"/>
-          </ac:picMkLst>
-        </pc:picChg>
-      </pc:sldChg>
+            <pc:sldMasterMk cId="3373909067" sldId="2147483648"/>
+            <pc:sldLayoutMk cId="2925915656" sldId="2147483649"/>
+          </pc:sldLayoutMkLst>
+        </pc:sldLayoutChg>
+        <pc:sldLayoutChg chg="setBg">
+          <pc:chgData name="Ziv Abraham" userId="c4913433ebff2b9d" providerId="LiveId" clId="{3DCE9E76-4607-4482-828F-6A8054342288}" dt="2026-05-03T07:45:30.176" v="2821"/>
+          <pc:sldLayoutMkLst>
+            <pc:docMk/>
+            <pc:sldMasterMk cId="3373909067" sldId="2147483648"/>
+            <pc:sldLayoutMk cId="917500248" sldId="2147483650"/>
+          </pc:sldLayoutMkLst>
+        </pc:sldLayoutChg>
+        <pc:sldLayoutChg chg="setBg">
+          <pc:chgData name="Ziv Abraham" userId="c4913433ebff2b9d" providerId="LiveId" clId="{3DCE9E76-4607-4482-828F-6A8054342288}" dt="2026-05-03T07:45:30.176" v="2821"/>
+          <pc:sldLayoutMkLst>
+            <pc:docMk/>
+            <pc:sldMasterMk cId="3373909067" sldId="2147483648"/>
+            <pc:sldLayoutMk cId="1975641075" sldId="2147483651"/>
+          </pc:sldLayoutMkLst>
+        </pc:sldLayoutChg>
+        <pc:sldLayoutChg chg="setBg">
+          <pc:chgData name="Ziv Abraham" userId="c4913433ebff2b9d" providerId="LiveId" clId="{3DCE9E76-4607-4482-828F-6A8054342288}" dt="2026-05-03T07:45:30.176" v="2821"/>
+          <pc:sldLayoutMkLst>
+            <pc:docMk/>
+            <pc:sldMasterMk cId="3373909067" sldId="2147483648"/>
+            <pc:sldLayoutMk cId="1954048804" sldId="2147483652"/>
+          </pc:sldLayoutMkLst>
+        </pc:sldLayoutChg>
+        <pc:sldLayoutChg chg="setBg">
+          <pc:chgData name="Ziv Abraham" userId="c4913433ebff2b9d" providerId="LiveId" clId="{3DCE9E76-4607-4482-828F-6A8054342288}" dt="2026-05-03T07:45:30.176" v="2821"/>
+          <pc:sldLayoutMkLst>
+            <pc:docMk/>
+            <pc:sldMasterMk cId="3373909067" sldId="2147483648"/>
+            <pc:sldLayoutMk cId="1366907591" sldId="2147483653"/>
+          </pc:sldLayoutMkLst>
+        </pc:sldLayoutChg>
+        <pc:sldLayoutChg chg="setBg">
+          <pc:chgData name="Ziv Abraham" userId="c4913433ebff2b9d" providerId="LiveId" clId="{3DCE9E76-4607-4482-828F-6A8054342288}" dt="2026-05-03T07:45:30.176" v="2821"/>
+          <pc:sldLayoutMkLst>
+            <pc:docMk/>
+            <pc:sldMasterMk cId="3373909067" sldId="2147483648"/>
+            <pc:sldLayoutMk cId="436313674" sldId="2147483654"/>
+          </pc:sldLayoutMkLst>
+        </pc:sldLayoutChg>
+        <pc:sldLayoutChg chg="setBg">
+          <pc:chgData name="Ziv Abraham" userId="c4913433ebff2b9d" providerId="LiveId" clId="{3DCE9E76-4607-4482-828F-6A8054342288}" dt="2026-05-03T07:45:30.176" v="2821"/>
+          <pc:sldLayoutMkLst>
+            <pc:docMk/>
+            <pc:sldMasterMk cId="3373909067" sldId="2147483648"/>
+            <pc:sldLayoutMk cId="549947034" sldId="2147483655"/>
+          </pc:sldLayoutMkLst>
+        </pc:sldLayoutChg>
+        <pc:sldLayoutChg chg="setBg">
+          <pc:chgData name="Ziv Abraham" userId="c4913433ebff2b9d" providerId="LiveId" clId="{3DCE9E76-4607-4482-828F-6A8054342288}" dt="2026-05-03T07:45:30.176" v="2821"/>
+          <pc:sldLayoutMkLst>
+            <pc:docMk/>
+            <pc:sldMasterMk cId="3373909067" sldId="2147483648"/>
+            <pc:sldLayoutMk cId="1973093944" sldId="2147483656"/>
+          </pc:sldLayoutMkLst>
+        </pc:sldLayoutChg>
+        <pc:sldLayoutChg chg="setBg">
+          <pc:chgData name="Ziv Abraham" userId="c4913433ebff2b9d" providerId="LiveId" clId="{3DCE9E76-4607-4482-828F-6A8054342288}" dt="2026-05-03T07:45:30.176" v="2821"/>
+          <pc:sldLayoutMkLst>
+            <pc:docMk/>
+            <pc:sldMasterMk cId="3373909067" sldId="2147483648"/>
+            <pc:sldLayoutMk cId="221854052" sldId="2147483657"/>
+          </pc:sldLayoutMkLst>
+        </pc:sldLayoutChg>
+        <pc:sldLayoutChg chg="setBg">
+          <pc:chgData name="Ziv Abraham" userId="c4913433ebff2b9d" providerId="LiveId" clId="{3DCE9E76-4607-4482-828F-6A8054342288}" dt="2026-05-03T07:45:30.176" v="2821"/>
+          <pc:sldLayoutMkLst>
+            <pc:docMk/>
+            <pc:sldMasterMk cId="3373909067" sldId="2147483648"/>
+            <pc:sldLayoutMk cId="1031933270" sldId="2147483658"/>
+          </pc:sldLayoutMkLst>
+        </pc:sldLayoutChg>
+        <pc:sldLayoutChg chg="setBg">
+          <pc:chgData name="Ziv Abraham" userId="c4913433ebff2b9d" providerId="LiveId" clId="{3DCE9E76-4607-4482-828F-6A8054342288}" dt="2026-05-03T07:45:30.176" v="2821"/>
+          <pc:sldLayoutMkLst>
+            <pc:docMk/>
+            <pc:sldMasterMk cId="3373909067" sldId="2147483648"/>
+            <pc:sldLayoutMk cId="4120495355" sldId="2147483659"/>
+          </pc:sldLayoutMkLst>
+        </pc:sldLayoutChg>
+      </pc:sldMasterChg>
     </pc:docChg>
   </pc:docChgLst>
 </pc:chgInfo>
@@ -881,7 +600,7 @@
           <a:p>
             <a:fld id="{41EB46D8-069D-459E-B16B-339FA4F901E8}" type="datetimeFigureOut">
               <a:rPr lang="LID4096" smtClean="0"/>
-              <a:t>05/01/2026</a:t>
+              <a:t>05/03/2026</a:t>
             </a:fld>
             <a:endParaRPr lang="LID4096"/>
           </a:p>
@@ -1081,7 +800,7 @@
           <a:p>
             <a:fld id="{41EB46D8-069D-459E-B16B-339FA4F901E8}" type="datetimeFigureOut">
               <a:rPr lang="LID4096" smtClean="0"/>
-              <a:t>05/01/2026</a:t>
+              <a:t>05/03/2026</a:t>
             </a:fld>
             <a:endParaRPr lang="LID4096"/>
           </a:p>
@@ -1291,7 +1010,7 @@
           <a:p>
             <a:fld id="{41EB46D8-069D-459E-B16B-339FA4F901E8}" type="datetimeFigureOut">
               <a:rPr lang="LID4096" smtClean="0"/>
-              <a:t>05/01/2026</a:t>
+              <a:t>05/03/2026</a:t>
             </a:fld>
             <a:endParaRPr lang="LID4096"/>
           </a:p>
@@ -1491,7 +1210,7 @@
           <a:p>
             <a:fld id="{41EB46D8-069D-459E-B16B-339FA4F901E8}" type="datetimeFigureOut">
               <a:rPr lang="LID4096" smtClean="0"/>
-              <a:t>05/01/2026</a:t>
+              <a:t>05/03/2026</a:t>
             </a:fld>
             <a:endParaRPr lang="LID4096"/>
           </a:p>
@@ -1767,7 +1486,7 @@
           <a:p>
             <a:fld id="{41EB46D8-069D-459E-B16B-339FA4F901E8}" type="datetimeFigureOut">
               <a:rPr lang="LID4096" smtClean="0"/>
-              <a:t>05/01/2026</a:t>
+              <a:t>05/03/2026</a:t>
             </a:fld>
             <a:endParaRPr lang="LID4096"/>
           </a:p>
@@ -2035,7 +1754,7 @@
           <a:p>
             <a:fld id="{41EB46D8-069D-459E-B16B-339FA4F901E8}" type="datetimeFigureOut">
               <a:rPr lang="LID4096" smtClean="0"/>
-              <a:t>05/01/2026</a:t>
+              <a:t>05/03/2026</a:t>
             </a:fld>
             <a:endParaRPr lang="LID4096"/>
           </a:p>
@@ -2450,7 +2169,7 @@
           <a:p>
             <a:fld id="{41EB46D8-069D-459E-B16B-339FA4F901E8}" type="datetimeFigureOut">
               <a:rPr lang="LID4096" smtClean="0"/>
-              <a:t>05/01/2026</a:t>
+              <a:t>05/03/2026</a:t>
             </a:fld>
             <a:endParaRPr lang="LID4096"/>
           </a:p>
@@ -2592,7 +2311,7 @@
           <a:p>
             <a:fld id="{41EB46D8-069D-459E-B16B-339FA4F901E8}" type="datetimeFigureOut">
               <a:rPr lang="LID4096" smtClean="0"/>
-              <a:t>05/01/2026</a:t>
+              <a:t>05/03/2026</a:t>
             </a:fld>
             <a:endParaRPr lang="LID4096"/>
           </a:p>
@@ -2705,7 +2424,7 @@
           <a:p>
             <a:fld id="{41EB46D8-069D-459E-B16B-339FA4F901E8}" type="datetimeFigureOut">
               <a:rPr lang="LID4096" smtClean="0"/>
-              <a:t>05/01/2026</a:t>
+              <a:t>05/03/2026</a:t>
             </a:fld>
             <a:endParaRPr lang="LID4096"/>
           </a:p>
@@ -3018,7 +2737,7 @@
           <a:p>
             <a:fld id="{41EB46D8-069D-459E-B16B-339FA4F901E8}" type="datetimeFigureOut">
               <a:rPr lang="LID4096" smtClean="0"/>
-              <a:t>05/01/2026</a:t>
+              <a:t>05/03/2026</a:t>
             </a:fld>
             <a:endParaRPr lang="LID4096"/>
           </a:p>
@@ -3307,7 +3026,7 @@
           <a:p>
             <a:fld id="{41EB46D8-069D-459E-B16B-339FA4F901E8}" type="datetimeFigureOut">
               <a:rPr lang="LID4096" smtClean="0"/>
-              <a:t>05/01/2026</a:t>
+              <a:t>05/03/2026</a:t>
             </a:fld>
             <a:endParaRPr lang="LID4096"/>
           </a:p>
@@ -3384,9 +3103,12 @@
 <p:sldMaster xmlns:a="http://schemas.openxmlformats.org/drawingml/2006/main" xmlns:r="http://schemas.openxmlformats.org/officeDocument/2006/relationships" xmlns:p="http://schemas.openxmlformats.org/presentationml/2006/main">
   <p:cSld>
     <p:bg>
-      <p:bgRef idx="1001">
-        <a:schemeClr val="bg1"/>
-      </p:bgRef>
+      <p:bgPr>
+        <a:solidFill>
+          <a:srgbClr val="C1E5F5"/>
+        </a:solidFill>
+        <a:effectLst/>
+      </p:bgPr>
     </p:bg>
     <p:spTree>
       <p:nvGrpSpPr>
@@ -3550,7 +3272,7 @@
           <a:p>
             <a:fld id="{41EB46D8-069D-459E-B16B-339FA4F901E8}" type="datetimeFigureOut">
               <a:rPr lang="LID4096" smtClean="0"/>
-              <a:t>05/01/2026</a:t>
+              <a:t>05/03/2026</a:t>
             </a:fld>
             <a:endParaRPr lang="LID4096"/>
           </a:p>
@@ -3953,14 +3675,6 @@
 <file path=ppt/slides/slide1.xml><?xml version="1.0" encoding="utf-8"?>
 <p:sld xmlns:a="http://schemas.openxmlformats.org/drawingml/2006/main" xmlns:r="http://schemas.openxmlformats.org/officeDocument/2006/relationships" xmlns:p="http://schemas.openxmlformats.org/presentationml/2006/main">
   <p:cSld>
-    <p:bg>
-      <p:bgPr>
-        <a:solidFill>
-          <a:schemeClr val="bg1"/>
-        </a:solidFill>
-        <a:effectLst/>
-      </p:bgPr>
-    </p:bg>
     <p:spTree>
       <p:nvGrpSpPr>
         <p:cNvPr id="1" name=""/>
@@ -4338,14 +4052,6 @@
 <file path=ppt/slides/slide2.xml><?xml version="1.0" encoding="utf-8"?>
 <p:sld xmlns:a="http://schemas.openxmlformats.org/drawingml/2006/main" xmlns:r="http://schemas.openxmlformats.org/officeDocument/2006/relationships" xmlns:p="http://schemas.openxmlformats.org/presentationml/2006/main">
   <p:cSld>
-    <p:bg>
-      <p:bgPr>
-        <a:solidFill>
-          <a:schemeClr val="bg1"/>
-        </a:solidFill>
-        <a:effectLst/>
-      </p:bgPr>
-    </p:bg>
     <p:spTree>
       <p:nvGrpSpPr>
         <p:cNvPr id="1" name="">
@@ -4445,24 +4151,20 @@
         <p:spPr>
           <a:xfrm>
             <a:off x="645064" y="525982"/>
-            <a:ext cx="4282983" cy="1200361"/>
+            <a:ext cx="4085686" cy="1200361"/>
           </a:xfrm>
         </p:spPr>
         <p:txBody>
           <a:bodyPr vert="horz" lIns="91440" tIns="45720" rIns="91440" bIns="45720" rtlCol="0" anchor="b">
-            <a:normAutofit/>
+            <a:noAutofit/>
           </a:bodyPr>
           <a:lstStyle/>
           <a:p>
             <a:pPr algn="l"/>
             <a:r>
-              <a:rPr lang="en-US" sz="3600" u="sng" kern="1200" dirty="0">
-                <a:solidFill>
-                  <a:schemeClr val="tx1"/>
-                </a:solidFill>
-                <a:latin typeface="+mj-lt"/>
-                <a:ea typeface="+mj-ea"/>
-                <a:cs typeface="+mj-cs"/>
+              <a:rPr lang="en-US" sz="3200" u="sng" dirty="0">
+                <a:latin typeface="Segoe UI Black" panose="020B0A02040204020203" pitchFamily="34" charset="0"/>
+                <a:ea typeface="Segoe UI Black" panose="020B0A02040204020203" pitchFamily="34" charset="0"/>
               </a:rPr>
               <a:t>Project description</a:t>
             </a:r>
@@ -4556,7 +4258,7 @@
         </p:spPr>
         <p:txBody>
           <a:bodyPr vert="horz" lIns="91440" tIns="45720" rIns="91440" bIns="45720" rtlCol="0" anchor="ctr">
-            <a:normAutofit/>
+            <a:normAutofit fontScale="92500" lnSpcReduction="20000"/>
           </a:bodyPr>
           <a:lstStyle/>
           <a:p>
@@ -4565,7 +4267,10 @@
               <a:buChar char="•"/>
             </a:pPr>
             <a:r>
-              <a:rPr lang="en-US" sz="1500" u="sng" dirty="0"/>
+              <a:rPr lang="en-US" sz="1800" dirty="0">
+                <a:latin typeface="Segoe UI" panose="020B0502040204020203" pitchFamily="34" charset="0"/>
+                <a:cs typeface="Segoe UI" panose="020B0502040204020203" pitchFamily="34" charset="0"/>
+              </a:rPr>
               <a:t>Hardware:</a:t>
             </a:r>
           </a:p>
@@ -4575,7 +4280,10 @@
               <a:buChar char="•"/>
             </a:pPr>
             <a:r>
-              <a:rPr lang="en-US" sz="1500" dirty="0"/>
+              <a:rPr lang="en-US" sz="1800" dirty="0">
+                <a:latin typeface="Segoe UI" panose="020B0502040204020203" pitchFamily="34" charset="0"/>
+                <a:cs typeface="Segoe UI" panose="020B0502040204020203" pitchFamily="34" charset="0"/>
+              </a:rPr>
               <a:t>Microchip – ESP32</a:t>
             </a:r>
           </a:p>
@@ -4585,7 +4293,10 @@
               <a:buChar char="•"/>
             </a:pPr>
             <a:r>
-              <a:rPr lang="en-US" sz="1500" dirty="0"/>
+              <a:rPr lang="en-US" sz="1800" dirty="0">
+                <a:latin typeface="Segoe UI" panose="020B0502040204020203" pitchFamily="34" charset="0"/>
+                <a:cs typeface="Segoe UI" panose="020B0502040204020203" pitchFamily="34" charset="0"/>
+              </a:rPr>
               <a:t>Microphone module</a:t>
             </a:r>
           </a:p>
@@ -4595,7 +4306,10 @@
               <a:buChar char="•"/>
             </a:pPr>
             <a:r>
-              <a:rPr lang="en-US" sz="1500" dirty="0"/>
+              <a:rPr lang="en-US" sz="1800" dirty="0">
+                <a:latin typeface="Segoe UI" panose="020B0502040204020203" pitchFamily="34" charset="0"/>
+                <a:cs typeface="Segoe UI" panose="020B0502040204020203" pitchFamily="34" charset="0"/>
+              </a:rPr>
               <a:t>NE5532 OP-AMP with X22 Amplification</a:t>
             </a:r>
           </a:p>
@@ -4605,7 +4319,10 @@
               <a:buChar char="•"/>
             </a:pPr>
             <a:r>
-              <a:rPr lang="en-US" sz="1500" u="sng" dirty="0"/>
+              <a:rPr lang="en-US" sz="1800" dirty="0">
+                <a:latin typeface="Segoe UI" panose="020B0502040204020203" pitchFamily="34" charset="0"/>
+                <a:cs typeface="Segoe UI" panose="020B0502040204020203" pitchFamily="34" charset="0"/>
+              </a:rPr>
               <a:t>Software:</a:t>
             </a:r>
           </a:p>
@@ -4615,7 +4332,10 @@
               <a:buChar char="•"/>
             </a:pPr>
             <a:r>
-              <a:rPr lang="en-US" sz="1500" dirty="0"/>
+              <a:rPr lang="en-US" sz="1800" dirty="0">
+                <a:latin typeface="Segoe UI" panose="020B0502040204020203" pitchFamily="34" charset="0"/>
+                <a:cs typeface="Segoe UI" panose="020B0502040204020203" pitchFamily="34" charset="0"/>
+              </a:rPr>
               <a:t>C++, JS</a:t>
             </a:r>
           </a:p>
@@ -4625,19 +4345,31 @@
               <a:buChar char="•"/>
             </a:pPr>
             <a:r>
-              <a:rPr lang="en-US" sz="1500" dirty="0" err="1"/>
+              <a:rPr lang="en-US" sz="1800" dirty="0" err="1">
+                <a:latin typeface="Segoe UI" panose="020B0502040204020203" pitchFamily="34" charset="0"/>
+                <a:cs typeface="Segoe UI" panose="020B0502040204020203" pitchFamily="34" charset="0"/>
+              </a:rPr>
               <a:t>PlatformIO</a:t>
             </a:r>
             <a:r>
-              <a:rPr lang="en-US" sz="1500" dirty="0"/>
+              <a:rPr lang="en-US" sz="1800" dirty="0">
+                <a:latin typeface="Segoe UI" panose="020B0502040204020203" pitchFamily="34" charset="0"/>
+                <a:cs typeface="Segoe UI" panose="020B0502040204020203" pitchFamily="34" charset="0"/>
+              </a:rPr>
               <a:t>, </a:t>
             </a:r>
             <a:r>
-              <a:rPr lang="en-US" sz="1500" dirty="0" err="1"/>
+              <a:rPr lang="en-US" sz="1800" dirty="0" err="1">
+                <a:latin typeface="Segoe UI" panose="020B0502040204020203" pitchFamily="34" charset="0"/>
+                <a:cs typeface="Segoe UI" panose="020B0502040204020203" pitchFamily="34" charset="0"/>
+              </a:rPr>
               <a:t>arduinoFFT</a:t>
             </a:r>
             <a:r>
-              <a:rPr lang="en-US" sz="1500" dirty="0"/>
+              <a:rPr lang="en-US" sz="1800" dirty="0">
+                <a:latin typeface="Segoe UI" panose="020B0502040204020203" pitchFamily="34" charset="0"/>
+                <a:cs typeface="Segoe UI" panose="020B0502040204020203" pitchFamily="34" charset="0"/>
+              </a:rPr>
               <a:t> library</a:t>
             </a:r>
           </a:p>
@@ -4647,7 +4379,10 @@
               <a:buChar char="•"/>
             </a:pPr>
             <a:r>
-              <a:rPr lang="en-US" sz="1500" u="sng" dirty="0"/>
+              <a:rPr lang="en-US" sz="1800" dirty="0">
+                <a:latin typeface="Segoe UI" panose="020B0502040204020203" pitchFamily="34" charset="0"/>
+                <a:cs typeface="Segoe UI" panose="020B0502040204020203" pitchFamily="34" charset="0"/>
+              </a:rPr>
               <a:t>AI tools used:</a:t>
             </a:r>
           </a:p>
@@ -4657,7 +4392,10 @@
               <a:buChar char="•"/>
             </a:pPr>
             <a:r>
-              <a:rPr lang="en-US" sz="1500" dirty="0"/>
+              <a:rPr lang="en-US" sz="1800" dirty="0">
+                <a:latin typeface="Segoe UI" panose="020B0502040204020203" pitchFamily="34" charset="0"/>
+                <a:cs typeface="Segoe UI" panose="020B0502040204020203" pitchFamily="34" charset="0"/>
+              </a:rPr>
               <a:t>Gemini for design and planning</a:t>
             </a:r>
           </a:p>
@@ -4667,11 +4405,17 @@
               <a:buChar char="•"/>
             </a:pPr>
             <a:r>
-              <a:rPr lang="en-US" sz="1500" dirty="0" err="1"/>
+              <a:rPr lang="en-US" sz="1800" dirty="0" err="1">
+                <a:latin typeface="Segoe UI" panose="020B0502040204020203" pitchFamily="34" charset="0"/>
+                <a:cs typeface="Segoe UI" panose="020B0502040204020203" pitchFamily="34" charset="0"/>
+              </a:rPr>
               <a:t>Github</a:t>
             </a:r>
             <a:r>
-              <a:rPr lang="en-US" sz="1500" dirty="0"/>
+              <a:rPr lang="en-US" sz="1800" dirty="0">
+                <a:latin typeface="Segoe UI" panose="020B0502040204020203" pitchFamily="34" charset="0"/>
+                <a:cs typeface="Segoe UI" panose="020B0502040204020203" pitchFamily="34" charset="0"/>
+              </a:rPr>
               <a:t> Copilot for code writing</a:t>
             </a:r>
           </a:p>
@@ -4919,14 +4663,6 @@
 <file path=ppt/slides/slide3.xml><?xml version="1.0" encoding="utf-8"?>
 <p:sld xmlns:a="http://schemas.openxmlformats.org/drawingml/2006/main" xmlns:r="http://schemas.openxmlformats.org/officeDocument/2006/relationships" xmlns:p="http://schemas.openxmlformats.org/presentationml/2006/main">
   <p:cSld>
-    <p:bg>
-      <p:bgPr>
-        <a:solidFill>
-          <a:srgbClr val="C1E5F5"/>
-        </a:solidFill>
-        <a:effectLst/>
-      </p:bgPr>
-    </p:bg>
     <p:spTree>
       <p:nvGrpSpPr>
         <p:cNvPr id="1" name="">
@@ -4977,10 +4713,16 @@
           <a:p>
             <a:pPr algn="l"/>
             <a:r>
-              <a:rPr lang="en-US" sz="4400" u="sng" dirty="0"/>
+              <a:rPr lang="en-US" sz="3200" u="sng" dirty="0">
+                <a:latin typeface="Segoe UI Black" panose="020B0A02040204020203" pitchFamily="34" charset="0"/>
+                <a:ea typeface="Segoe UI Black" panose="020B0A02040204020203" pitchFamily="34" charset="0"/>
+              </a:rPr>
               <a:t>The Math</a:t>
             </a:r>
-            <a:endParaRPr lang="LID4096" sz="4400" u="sng" dirty="0"/>
+            <a:endParaRPr lang="LID4096" sz="3200" u="sng" dirty="0">
+              <a:latin typeface="Segoe UI Black" panose="020B0A02040204020203" pitchFamily="34" charset="0"/>
+              <a:ea typeface="Segoe UI Black" panose="020B0A02040204020203" pitchFamily="34" charset="0"/>
+            </a:endParaRPr>
           </a:p>
         </p:txBody>
       </p:sp>
@@ -5016,7 +4758,10 @@
               <a:p>
                 <a:pPr algn="l"/>
                 <a:r>
-                  <a:rPr lang="en-US" sz="1800" dirty="0"/>
+                  <a:rPr lang="en-US" sz="1800" dirty="0">
+                    <a:latin typeface="Segoe UI" panose="020B0502040204020203" pitchFamily="34" charset="0"/>
+                    <a:cs typeface="Segoe UI" panose="020B0502040204020203" pitchFamily="34" charset="0"/>
+                  </a:rPr>
                   <a:t>Sampling rate </a:t>
                 </a:r>
                 <a14:m>
@@ -5067,7 +4812,10 @@
                   </m:oMath>
                 </a14:m>
                 <a:r>
-                  <a:rPr lang="en-US" sz="1800" dirty="0"/>
+                  <a:rPr lang="en-US" sz="1800" dirty="0">
+                    <a:latin typeface="Segoe UI" panose="020B0502040204020203" pitchFamily="34" charset="0"/>
+                    <a:cs typeface="Segoe UI" panose="020B0502040204020203" pitchFamily="34" charset="0"/>
+                  </a:rPr>
                   <a:t> Maximum “viewable” frequency of </a:t>
                 </a:r>
                 <a14:m>
@@ -5087,14 +4835,20 @@
                   </m:oMath>
                 </a14:m>
                 <a:r>
-                  <a:rPr lang="en-US" sz="1800" dirty="0"/>
+                  <a:rPr lang="en-US" sz="1800" dirty="0">
+                    <a:latin typeface="Segoe UI" panose="020B0502040204020203" pitchFamily="34" charset="0"/>
+                    <a:cs typeface="Segoe UI" panose="020B0502040204020203" pitchFamily="34" charset="0"/>
+                  </a:rPr>
                   <a:t> (Nyquist).</a:t>
                 </a:r>
               </a:p>
               <a:p>
                 <a:pPr algn="l"/>
                 <a:r>
-                  <a:rPr lang="en-US" sz="1800" dirty="0"/>
+                  <a:rPr lang="en-US" sz="1800" dirty="0">
+                    <a:latin typeface="Segoe UI" panose="020B0502040204020203" pitchFamily="34" charset="0"/>
+                    <a:cs typeface="Segoe UI" panose="020B0502040204020203" pitchFamily="34" charset="0"/>
+                  </a:rPr>
                   <a:t>Number of samples </a:t>
                 </a:r>
                 <a14:m>
@@ -5109,54 +4863,103 @@
                       <a:rPr lang="en-US" sz="1800" b="0" i="1" smtClean="0">
                         <a:latin typeface="Cambria Math" panose="02040503050406030204" pitchFamily="18" charset="0"/>
                       </a:rPr>
-                      <m:t>=2048</m:t>
+                      <m:t>=512</m:t>
                     </m:r>
                   </m:oMath>
                 </a14:m>
                 <a:r>
-                  <a:rPr lang="en-US" sz="1800" b="0" dirty="0"/>
-                  <a:t> : The number of samples we send in each block to perform the FFT.</a:t>
+                  <a:rPr lang="en-US" sz="1800" b="0" dirty="0">
+                    <a:latin typeface="Segoe UI" panose="020B0502040204020203" pitchFamily="34" charset="0"/>
+                    <a:cs typeface="Segoe UI" panose="020B0502040204020203" pitchFamily="34" charset="0"/>
+                  </a:rPr>
+                  <a:t>  - The number of samples we send in each block to perform the FFT.</a:t>
                 </a:r>
               </a:p>
               <a:p>
                 <a:pPr algn="l"/>
                 <a:r>
-                  <a:rPr lang="en-US" sz="1800" dirty="0"/>
-                  <a:t>Given the sampling rate, we get </a:t>
+                  <a:rPr lang="en-US" sz="1800" dirty="0">
+                    <a:latin typeface="Segoe UI" panose="020B0502040204020203" pitchFamily="34" charset="0"/>
+                    <a:cs typeface="Segoe UI" panose="020B0502040204020203" pitchFamily="34" charset="0"/>
+                  </a:rPr>
+                  <a:t>Given the sampling rate, we get 10 samples</a:t>
                 </a:r>
                 <a:r>
-                  <a:rPr lang="en-US" sz="1800" b="1" dirty="0"/>
-                  <a:t>10 samples </a:t>
+                  <a:rPr lang="en-US" sz="1800" b="1" dirty="0">
+                    <a:latin typeface="Segoe UI" panose="020B0502040204020203" pitchFamily="34" charset="0"/>
+                    <a:cs typeface="Segoe UI" panose="020B0502040204020203" pitchFamily="34" charset="0"/>
+                  </a:rPr>
+                  <a:t> </a:t>
                 </a:r>
                 <a:r>
-                  <a:rPr lang="en-US" sz="1800" dirty="0"/>
+                  <a:rPr lang="en-US" sz="1800" dirty="0">
+                    <a:latin typeface="Segoe UI" panose="020B0502040204020203" pitchFamily="34" charset="0"/>
+                    <a:cs typeface="Segoe UI" panose="020B0502040204020203" pitchFamily="34" charset="0"/>
+                  </a:rPr>
                   <a:t>every 1 millisecond, it takes </a:t>
                 </a:r>
                 <a14:m>
                   <m:oMath xmlns:m="http://schemas.openxmlformats.org/officeDocument/2006/math">
                     <m:r>
-                      <a:rPr lang="en-US" sz="1800" b="0" i="1" smtClean="0">
+                      <a:rPr lang="en-US" sz="1800" b="1" i="1" smtClean="0">
                         <a:latin typeface="Cambria Math" panose="02040503050406030204" pitchFamily="18" charset="0"/>
                       </a:rPr>
-                      <m:t>204.8 </m:t>
+                      <m:t>𝟓𝟏</m:t>
                     </m:r>
                     <m:r>
-                      <a:rPr lang="en-US" sz="1800" b="0" i="1" smtClean="0">
+                      <a:rPr lang="en-US" sz="1800" b="1" i="1" smtClean="0">
                         <a:latin typeface="Cambria Math" panose="02040503050406030204" pitchFamily="18" charset="0"/>
                       </a:rPr>
-                      <m:t>𝑚𝑠</m:t>
+                      <m:t>.</m:t>
+                    </m:r>
+                    <m:r>
+                      <a:rPr lang="en-US" sz="1800" b="1" i="1" smtClean="0">
+                        <a:latin typeface="Cambria Math" panose="02040503050406030204" pitchFamily="18" charset="0"/>
+                      </a:rPr>
+                      <m:t>𝟐</m:t>
+                    </m:r>
+                    <m:r>
+                      <a:rPr lang="en-US" sz="1800" b="1" i="1" smtClean="0">
+                        <a:latin typeface="Cambria Math" panose="02040503050406030204" pitchFamily="18" charset="0"/>
+                      </a:rPr>
+                      <m:t> </m:t>
+                    </m:r>
+                    <m:r>
+                      <a:rPr lang="en-US" sz="1800" b="1" i="1" smtClean="0">
+                        <a:latin typeface="Cambria Math" panose="02040503050406030204" pitchFamily="18" charset="0"/>
+                      </a:rPr>
+                      <m:t>𝒎𝒔</m:t>
                     </m:r>
                   </m:oMath>
                 </a14:m>
                 <a:r>
-                  <a:rPr lang="en-US" sz="1800" dirty="0"/>
-                  <a:t> in order to fill a block. This is the time limit to perform the calculations and to send them to the UI / Other processing needs. </a:t>
+                  <a:rPr lang="en-US" sz="1800" dirty="0">
+                    <a:latin typeface="Segoe UI" panose="020B0502040204020203" pitchFamily="34" charset="0"/>
+                    <a:cs typeface="Segoe UI" panose="020B0502040204020203" pitchFamily="34" charset="0"/>
+                  </a:rPr>
+                  <a:t> to fill a block. </a:t>
+                </a:r>
+                <a:br>
+                  <a:rPr lang="en-US" sz="1800" dirty="0">
+                    <a:latin typeface="Segoe UI" panose="020B0502040204020203" pitchFamily="34" charset="0"/>
+                    <a:cs typeface="Segoe UI" panose="020B0502040204020203" pitchFamily="34" charset="0"/>
+                  </a:rPr>
+                </a:br>
+                <a:r>
+                  <a:rPr lang="en-US" sz="1800" dirty="0">
+                    <a:latin typeface="Segoe UI" panose="020B0502040204020203" pitchFamily="34" charset="0"/>
+                    <a:cs typeface="Segoe UI" panose="020B0502040204020203" pitchFamily="34" charset="0"/>
+                  </a:rPr>
+                  <a:t>This is the time limit to perform calculations and sending them to the UI / Other processing needs. </a:t>
                 </a:r>
               </a:p>
               <a:p>
                 <a:pPr algn="l"/>
                 <a:r>
-                  <a:rPr lang="en-US" sz="1800" dirty="0"/>
+                  <a:rPr lang="en-US" sz="1800" dirty="0">
+                    <a:latin typeface="Segoe UI" panose="020B0502040204020203" pitchFamily="34" charset="0"/>
+                    <a:cs typeface="Segoe UI" panose="020B0502040204020203" pitchFamily="34" charset="0"/>
+                  </a:rPr>
                   <a:t>The ESP-32 has a </a:t>
                 </a:r>
                 <a14:m>
@@ -5176,33 +4979,60 @@
                   </m:oMath>
                 </a14:m>
                 <a:r>
-                  <a:rPr lang="en-US" sz="1800" dirty="0"/>
+                  <a:rPr lang="en-US" sz="1800" dirty="0">
+                    <a:latin typeface="Segoe UI" panose="020B0502040204020203" pitchFamily="34" charset="0"/>
+                    <a:cs typeface="Segoe UI" panose="020B0502040204020203" pitchFamily="34" charset="0"/>
+                  </a:rPr>
                   <a:t> CPU clock, assuming each complex multiplication takes around 10 cycles, we get </a:t>
                 </a:r>
                 <a14:m>
                   <m:oMath xmlns:m="http://schemas.openxmlformats.org/officeDocument/2006/math">
                     <m:r>
-                      <a:rPr lang="en-US" sz="1800" b="0" i="1" smtClean="0">
+                      <a:rPr lang="en-US" sz="1800" b="1" i="1" smtClean="0">
                         <a:latin typeface="Cambria Math" panose="02040503050406030204" pitchFamily="18" charset="0"/>
                       </a:rPr>
-                      <m:t>62.5 </m:t>
+                      <m:t>𝟔𝟐</m:t>
                     </m:r>
                     <m:r>
-                      <a:rPr lang="en-US" sz="1800" b="0" i="1" smtClean="0">
+                      <a:rPr lang="en-US" sz="1800" b="1" i="1" smtClean="0">
                         <a:latin typeface="Cambria Math" panose="02040503050406030204" pitchFamily="18" charset="0"/>
                       </a:rPr>
-                      <m:t>𝑛𝑠</m:t>
+                      <m:t>.</m:t>
+                    </m:r>
+                    <m:r>
+                      <a:rPr lang="en-US" sz="1800" b="1" i="1" smtClean="0">
+                        <a:latin typeface="Cambria Math" panose="02040503050406030204" pitchFamily="18" charset="0"/>
+                      </a:rPr>
+                      <m:t>𝟓</m:t>
+                    </m:r>
+                    <m:r>
+                      <a:rPr lang="en-US" sz="1800" b="1" i="1" smtClean="0">
+                        <a:latin typeface="Cambria Math" panose="02040503050406030204" pitchFamily="18" charset="0"/>
+                      </a:rPr>
+                      <m:t> </m:t>
+                    </m:r>
+                    <m:r>
+                      <a:rPr lang="en-US" sz="1800" b="1" i="1" smtClean="0">
+                        <a:latin typeface="Cambria Math" panose="02040503050406030204" pitchFamily="18" charset="0"/>
+                      </a:rPr>
+                      <m:t>𝒏𝒔</m:t>
                     </m:r>
                   </m:oMath>
                 </a14:m>
                 <a:r>
-                  <a:rPr lang="en-US" sz="1800" dirty="0"/>
+                  <a:rPr lang="en-US" sz="1800" b="1" dirty="0">
+                    <a:latin typeface="Segoe UI" panose="020B0502040204020203" pitchFamily="34" charset="0"/>
+                    <a:cs typeface="Segoe UI" panose="020B0502040204020203" pitchFamily="34" charset="0"/>
+                  </a:rPr>
                   <a:t> per operation.</a:t>
                 </a:r>
               </a:p>
               <a:p>
                 <a:pPr algn="l"/>
-                <a:endParaRPr lang="en-US" sz="1800" dirty="0"/>
+                <a:endParaRPr lang="en-US" sz="1800" dirty="0">
+                  <a:latin typeface="Segoe UI" panose="020B0502040204020203" pitchFamily="34" charset="0"/>
+                  <a:cs typeface="Segoe UI" panose="020B0502040204020203" pitchFamily="34" charset="0"/>
+                </a:endParaRPr>
               </a:p>
             </p:txBody>
           </p:sp>
@@ -5232,7 +5062,7 @@
               <a:blipFill>
                 <a:blip r:embed="rId2"/>
                 <a:stretch>
-                  <a:fillRect l="-463" t="-3030" r="-521" b="-2121"/>
+                  <a:fillRect l="-463" t="-3030" b="-2121"/>
                 </a:stretch>
               </a:blipFill>
             </p:spPr>
@@ -5268,7 +5098,7 @@
               <p:nvPr>
                 <p:extLst>
                   <p:ext uri="{D42A27DB-BD31-4B8C-83A1-F6EECF244321}">
-                    <p14:modId xmlns:p14="http://schemas.microsoft.com/office/powerpoint/2010/main" val="2367072675"/>
+                    <p14:modId xmlns:p14="http://schemas.microsoft.com/office/powerpoint/2010/main" val="551689051"/>
                   </p:ext>
                 </p:extLst>
               </p:nvPr>
@@ -5480,7 +5310,13 @@
                                   <a:rPr lang="en-US" b="0" i="1" smtClean="0">
                                     <a:latin typeface="Cambria Math" panose="02040503050406030204" pitchFamily="18" charset="0"/>
                                   </a:rPr>
-                                  <m:t>2048⋅</m:t>
+                                  <m:t>512</m:t>
+                                </m:r>
+                                <m:r>
+                                  <a:rPr lang="en-US" b="0" i="1" smtClean="0">
+                                    <a:latin typeface="Cambria Math" panose="02040503050406030204" pitchFamily="18" charset="0"/>
+                                  </a:rPr>
+                                  <m:t>⋅</m:t>
                                 </m:r>
                                 <m:func>
                                   <m:funcPr>
@@ -5515,7 +5351,7 @@
                                           <a:rPr lang="en-US" b="0" i="1" smtClean="0">
                                             <a:latin typeface="Cambria Math" panose="02040503050406030204" pitchFamily="18" charset="0"/>
                                           </a:rPr>
-                                          <m:t>2048</m:t>
+                                          <m:t>512</m:t>
                                         </m:r>
                                       </m:e>
                                     </m:d>
@@ -5525,7 +5361,13 @@
                                   <a:rPr lang="en-US" b="0" i="1" smtClean="0">
                                     <a:latin typeface="Cambria Math" panose="02040503050406030204" pitchFamily="18" charset="0"/>
                                   </a:rPr>
-                                  <m:t>=22,528</m:t>
+                                  <m:t>=</m:t>
+                                </m:r>
+                                <m:r>
+                                  <a:rPr lang="en-US" b="0" i="1" smtClean="0">
+                                    <a:latin typeface="Cambria Math" panose="02040503050406030204" pitchFamily="18" charset="0"/>
+                                  </a:rPr>
+                                  <m:t>4608</m:t>
                                 </m:r>
                               </m:oMath>
                             </m:oMathPara>
@@ -5560,7 +5402,7 @@
                                       <a:rPr lang="en-US" b="0" i="1" smtClean="0">
                                         <a:latin typeface="Cambria Math" panose="02040503050406030204" pitchFamily="18" charset="0"/>
                                       </a:rPr>
-                                      <m:t>2048</m:t>
+                                      <m:t>512</m:t>
                                     </m:r>
                                   </m:e>
                                   <m:sup>
@@ -5576,33 +5418,8 @@
                                   <a:rPr lang="en-US" b="0" i="1" smtClean="0">
                                     <a:latin typeface="Cambria Math" panose="02040503050406030204" pitchFamily="18" charset="0"/>
                                   </a:rPr>
-                                  <m:t>≈4.194×</m:t>
+                                  <m:t>=262144</m:t>
                                 </m:r>
-                                <m:sSup>
-                                  <m:sSupPr>
-                                    <m:ctrlPr>
-                                      <a:rPr lang="en-US" b="0" i="1" smtClean="0">
-                                        <a:latin typeface="Cambria Math" panose="02040503050406030204" pitchFamily="18" charset="0"/>
-                                      </a:rPr>
-                                    </m:ctrlPr>
-                                  </m:sSupPr>
-                                  <m:e>
-                                    <m:r>
-                                      <a:rPr lang="en-US" b="0" i="1" smtClean="0">
-                                        <a:latin typeface="Cambria Math" panose="02040503050406030204" pitchFamily="18" charset="0"/>
-                                      </a:rPr>
-                                      <m:t>10</m:t>
-                                    </m:r>
-                                  </m:e>
-                                  <m:sup>
-                                    <m:r>
-                                      <a:rPr lang="en-US" b="0" i="1" smtClean="0">
-                                        <a:latin typeface="Cambria Math" panose="02040503050406030204" pitchFamily="18" charset="0"/>
-                                      </a:rPr>
-                                      <m:t>6</m:t>
-                                    </m:r>
-                                  </m:sup>
-                                </m:sSup>
                               </m:oMath>
                             </m:oMathPara>
                           </a14:m>
@@ -5649,96 +5466,8 @@
                                   <a:rPr lang="en-US" b="0" i="1" smtClean="0">
                                     <a:latin typeface="Cambria Math" panose="02040503050406030204" pitchFamily="18" charset="0"/>
                                   </a:rPr>
-                                  <m:t>22528⋅62.5×</m:t>
+                                  <m:t>4608</m:t>
                                 </m:r>
-                                <m:sSup>
-                                  <m:sSupPr>
-                                    <m:ctrlPr>
-                                      <a:rPr lang="en-US" b="0" i="1" smtClean="0">
-                                        <a:latin typeface="Cambria Math" panose="02040503050406030204" pitchFamily="18" charset="0"/>
-                                      </a:rPr>
-                                    </m:ctrlPr>
-                                  </m:sSupPr>
-                                  <m:e>
-                                    <m:r>
-                                      <a:rPr lang="en-US" b="0" i="1" smtClean="0">
-                                        <a:latin typeface="Cambria Math" panose="02040503050406030204" pitchFamily="18" charset="0"/>
-                                      </a:rPr>
-                                      <m:t>10</m:t>
-                                    </m:r>
-                                  </m:e>
-                                  <m:sup>
-                                    <m:r>
-                                      <a:rPr lang="en-US" b="0" i="1" smtClean="0">
-                                        <a:latin typeface="Cambria Math" panose="02040503050406030204" pitchFamily="18" charset="0"/>
-                                      </a:rPr>
-                                      <m:t>−9</m:t>
-                                    </m:r>
-                                  </m:sup>
-                                </m:sSup>
-                                <m:r>
-                                  <a:rPr lang="en-US" b="0" i="1" smtClean="0">
-                                    <a:latin typeface="Cambria Math" panose="02040503050406030204" pitchFamily="18" charset="0"/>
-                                  </a:rPr>
-                                  <m:t>=1.4 </m:t>
-                                </m:r>
-                                <m:r>
-                                  <a:rPr lang="en-US" b="0" i="1" smtClean="0">
-                                    <a:latin typeface="Cambria Math" panose="02040503050406030204" pitchFamily="18" charset="0"/>
-                                  </a:rPr>
-                                  <m:t>𝑚𝑠</m:t>
-                                </m:r>
-                                <m:r>
-                                  <a:rPr lang="en-US" b="0" i="1" smtClean="0">
-                                    <a:latin typeface="Cambria Math" panose="02040503050406030204" pitchFamily="18" charset="0"/>
-                                  </a:rPr>
-                                  <m:t> </m:t>
-                                </m:r>
-                              </m:oMath>
-                            </m:oMathPara>
-                          </a14:m>
-                          <a:endParaRPr lang="LID4096" dirty="0"/>
-                        </a:p>
-                      </a:txBody>
-                      <a:tcPr/>
-                    </a:tc>
-                    <a:tc>
-                      <a:txBody>
-                        <a:bodyPr/>
-                        <a:lstStyle/>
-                        <a:p>
-                          <a:pPr algn="ctr"/>
-                          <a14:m>
-                            <m:oMathPara xmlns:m="http://schemas.openxmlformats.org/officeDocument/2006/math">
-                              <m:oMathParaPr>
-                                <m:jc m:val="centerGroup"/>
-                              </m:oMathParaPr>
-                              <m:oMath xmlns:m="http://schemas.openxmlformats.org/officeDocument/2006/math">
-                                <m:sSup>
-                                  <m:sSupPr>
-                                    <m:ctrlPr>
-                                      <a:rPr lang="en-US" b="0" i="1" smtClean="0">
-                                        <a:latin typeface="Cambria Math" panose="02040503050406030204" pitchFamily="18" charset="0"/>
-                                      </a:rPr>
-                                    </m:ctrlPr>
-                                  </m:sSupPr>
-                                  <m:e>
-                                    <m:r>
-                                      <a:rPr lang="en-US" b="0" i="1" smtClean="0">
-                                        <a:latin typeface="Cambria Math" panose="02040503050406030204" pitchFamily="18" charset="0"/>
-                                      </a:rPr>
-                                      <m:t>2048</m:t>
-                                    </m:r>
-                                  </m:e>
-                                  <m:sup>
-                                    <m:r>
-                                      <a:rPr lang="en-US" b="0" i="1" smtClean="0">
-                                        <a:latin typeface="Cambria Math" panose="02040503050406030204" pitchFamily="18" charset="0"/>
-                                      </a:rPr>
-                                      <m:t>2</m:t>
-                                    </m:r>
-                                  </m:sup>
-                                </m:sSup>
                                 <m:r>
                                   <a:rPr lang="en-US" b="0" i="1" smtClean="0">
                                     <a:latin typeface="Cambria Math" panose="02040503050406030204" pitchFamily="18" charset="0"/>
@@ -5774,7 +5503,106 @@
                                   <a:rPr lang="en-US" b="0" i="1" smtClean="0">
                                     <a:latin typeface="Cambria Math" panose="02040503050406030204" pitchFamily="18" charset="0"/>
                                   </a:rPr>
-                                  <m:t>≈262 </m:t>
+                                  <m:t>=</m:t>
+                                </m:r>
+                                <m:r>
+                                  <a:rPr lang="en-US" b="0" i="1" smtClean="0">
+                                    <a:latin typeface="Cambria Math" panose="02040503050406030204" pitchFamily="18" charset="0"/>
+                                  </a:rPr>
+                                  <m:t>0.288</m:t>
+                                </m:r>
+                                <m:r>
+                                  <a:rPr lang="en-US" b="0" i="1" smtClean="0">
+                                    <a:latin typeface="Cambria Math" panose="02040503050406030204" pitchFamily="18" charset="0"/>
+                                  </a:rPr>
+                                  <m:t> </m:t>
+                                </m:r>
+                                <m:r>
+                                  <a:rPr lang="en-US" b="0" i="1" smtClean="0">
+                                    <a:latin typeface="Cambria Math" panose="02040503050406030204" pitchFamily="18" charset="0"/>
+                                  </a:rPr>
+                                  <m:t>𝑚𝑠</m:t>
+                                </m:r>
+                                <m:r>
+                                  <a:rPr lang="en-US" b="0" i="1" smtClean="0">
+                                    <a:latin typeface="Cambria Math" panose="02040503050406030204" pitchFamily="18" charset="0"/>
+                                  </a:rPr>
+                                  <m:t> </m:t>
+                                </m:r>
+                              </m:oMath>
+                            </m:oMathPara>
+                          </a14:m>
+                          <a:endParaRPr lang="LID4096" dirty="0"/>
+                        </a:p>
+                      </a:txBody>
+                      <a:tcPr/>
+                    </a:tc>
+                    <a:tc>
+                      <a:txBody>
+                        <a:bodyPr/>
+                        <a:lstStyle/>
+                        <a:p>
+                          <a:pPr algn="ctr"/>
+                          <a14:m>
+                            <m:oMathPara xmlns:m="http://schemas.openxmlformats.org/officeDocument/2006/math">
+                              <m:oMathParaPr>
+                                <m:jc m:val="centerGroup"/>
+                              </m:oMathParaPr>
+                              <m:oMath xmlns:m="http://schemas.openxmlformats.org/officeDocument/2006/math">
+                                <m:r>
+                                  <a:rPr lang="en-US" b="0" i="1" smtClean="0">
+                                    <a:latin typeface="Cambria Math" panose="02040503050406030204" pitchFamily="18" charset="0"/>
+                                  </a:rPr>
+                                  <m:t>262144</m:t>
+                                </m:r>
+                                <m:r>
+                                  <a:rPr lang="en-US" b="0" i="1" smtClean="0">
+                                    <a:latin typeface="Cambria Math" panose="02040503050406030204" pitchFamily="18" charset="0"/>
+                                  </a:rPr>
+                                  <m:t>⋅62.5×</m:t>
+                                </m:r>
+                                <m:sSup>
+                                  <m:sSupPr>
+                                    <m:ctrlPr>
+                                      <a:rPr lang="en-US" b="0" i="1" smtClean="0">
+                                        <a:latin typeface="Cambria Math" panose="02040503050406030204" pitchFamily="18" charset="0"/>
+                                      </a:rPr>
+                                    </m:ctrlPr>
+                                  </m:sSupPr>
+                                  <m:e>
+                                    <m:r>
+                                      <a:rPr lang="en-US" b="0" i="1" smtClean="0">
+                                        <a:latin typeface="Cambria Math" panose="02040503050406030204" pitchFamily="18" charset="0"/>
+                                      </a:rPr>
+                                      <m:t>10</m:t>
+                                    </m:r>
+                                  </m:e>
+                                  <m:sup>
+                                    <m:r>
+                                      <a:rPr lang="en-US" b="0" i="1" smtClean="0">
+                                        <a:latin typeface="Cambria Math" panose="02040503050406030204" pitchFamily="18" charset="0"/>
+                                      </a:rPr>
+                                      <m:t>−9</m:t>
+                                    </m:r>
+                                  </m:sup>
+                                </m:sSup>
+                                <m:r>
+                                  <a:rPr lang="en-US" b="0" i="1" smtClean="0">
+                                    <a:latin typeface="Cambria Math" panose="02040503050406030204" pitchFamily="18" charset="0"/>
+                                  </a:rPr>
+                                  <m:t>≈</m:t>
+                                </m:r>
+                                <m:r>
+                                  <a:rPr lang="en-US" b="0" i="1" smtClean="0">
+                                    <a:latin typeface="Cambria Math" panose="02040503050406030204" pitchFamily="18" charset="0"/>
+                                  </a:rPr>
+                                  <m:t>16</m:t>
+                                </m:r>
+                                <m:r>
+                                  <a:rPr lang="en-US" b="0" i="1" smtClean="0">
+                                    <a:latin typeface="Cambria Math" panose="02040503050406030204" pitchFamily="18" charset="0"/>
+                                  </a:rPr>
+                                  <m:t> </m:t>
                                 </m:r>
                                 <m:r>
                                   <a:rPr lang="en-US" b="0" i="1" smtClean="0">
@@ -5817,7 +5645,7 @@
               <p:nvPr>
                 <p:extLst>
                   <p:ext uri="{D42A27DB-BD31-4B8C-83A1-F6EECF244321}">
-                    <p14:modId xmlns:p14="http://schemas.microsoft.com/office/powerpoint/2010/main" val="2367072675"/>
+                    <p14:modId xmlns:p14="http://schemas.microsoft.com/office/powerpoint/2010/main" val="551689051"/>
                   </p:ext>
                 </p:extLst>
               </p:nvPr>
@@ -6046,7 +5874,7 @@
             </p:nvSpPr>
             <p:spPr>
               <a:xfrm>
-                <a:off x="165099" y="5105780"/>
+                <a:off x="361949" y="4997830"/>
                 <a:ext cx="10759209" cy="825120"/>
               </a:xfrm>
               <a:prstGeom prst="rect">
@@ -6222,9 +6050,11 @@
                 </a:lvl9pPr>
               </a:lstStyle>
               <a:p>
-                <a:pPr algn="l"/>
                 <a:r>
-                  <a:rPr lang="en-US" sz="1800" dirty="0"/>
+                  <a:rPr lang="en-US" sz="1800" dirty="0">
+                    <a:latin typeface="Segoe UI" panose="020B0502040204020203" pitchFamily="34" charset="0"/>
+                    <a:cs typeface="Segoe UI" panose="020B0502040204020203" pitchFamily="34" charset="0"/>
+                  </a:rPr>
                   <a:t>While the FFT leaves </a:t>
                 </a:r>
                 <a14:m>
@@ -6233,7 +6063,13 @@
                       <a:rPr lang="en-US" sz="1800" b="0" i="1" smtClean="0">
                         <a:latin typeface="Cambria Math" panose="02040503050406030204" pitchFamily="18" charset="0"/>
                       </a:rPr>
-                      <m:t>203.4 </m:t>
+                      <m:t>51</m:t>
+                    </m:r>
+                    <m:r>
+                      <a:rPr lang="en-US" sz="1800" b="0" i="1" smtClean="0">
+                        <a:latin typeface="Cambria Math" panose="02040503050406030204" pitchFamily="18" charset="0"/>
+                      </a:rPr>
+                      <m:t> </m:t>
                     </m:r>
                     <m:r>
                       <a:rPr lang="en-US" sz="1800" b="0" i="1" smtClean="0">
@@ -6244,8 +6080,34 @@
                   </m:oMath>
                 </a14:m>
                 <a:r>
-                  <a:rPr lang="en-US" sz="1800" dirty="0"/>
-                  <a:t> for other operations, the naive DFT would never be on time to send the data, before the buffer fills again.  The FFT allows us to perform real time signal analysis.</a:t>
+                  <a:rPr lang="en-US" sz="1800" dirty="0">
+                    <a:latin typeface="Segoe UI" panose="020B0502040204020203" pitchFamily="34" charset="0"/>
+                    <a:cs typeface="Segoe UI" panose="020B0502040204020203" pitchFamily="34" charset="0"/>
+                  </a:rPr>
+                  <a:t> for other operations, the naive DFT would leave </a:t>
+                </a:r>
+                <a14:m>
+                  <m:oMath xmlns:m="http://schemas.openxmlformats.org/officeDocument/2006/math">
+                    <m:r>
+                      <a:rPr lang="en-US" sz="1800" b="0" i="1" smtClean="0">
+                        <a:latin typeface="Cambria Math" panose="02040503050406030204" pitchFamily="18" charset="0"/>
+                      </a:rPr>
+                      <m:t>35.2 </m:t>
+                    </m:r>
+                    <m:r>
+                      <a:rPr lang="en-US" sz="1800" b="0" i="1" smtClean="0">
+                        <a:latin typeface="Cambria Math" panose="02040503050406030204" pitchFamily="18" charset="0"/>
+                      </a:rPr>
+                      <m:t>𝑚𝑠</m:t>
+                    </m:r>
+                  </m:oMath>
+                </a14:m>
+                <a:r>
+                  <a:rPr lang="en-US" sz="1800" dirty="0">
+                    <a:latin typeface="Segoe UI" panose="020B0502040204020203" pitchFamily="34" charset="0"/>
+                    <a:cs typeface="Segoe UI" panose="020B0502040204020203" pitchFamily="34" charset="0"/>
+                  </a:rPr>
+                  <a:t>. </a:t>
                 </a:r>
               </a:p>
             </p:txBody>
@@ -6268,7 +6130,7 @@
             </p:nvSpPr>
             <p:spPr>
               <a:xfrm>
-                <a:off x="165099" y="5105780"/>
+                <a:off x="361949" y="4997830"/>
                 <a:ext cx="10759209" cy="825120"/>
               </a:xfrm>
               <a:prstGeom prst="rect">
@@ -6277,7 +6139,7 @@
               <a:blipFill>
                 <a:blip r:embed="rId4"/>
                 <a:stretch>
-                  <a:fillRect l="-453" t="-7407"/>
+                  <a:fillRect t="-7407"/>
                 </a:stretch>
               </a:blipFill>
             </p:spPr>
@@ -6300,6 +6162,774 @@
     <p:extLst>
       <p:ext uri="{BB962C8B-B14F-4D97-AF65-F5344CB8AC3E}">
         <p14:creationId xmlns:p14="http://schemas.microsoft.com/office/powerpoint/2010/main" val="1512192545"/>
+      </p:ext>
+    </p:extLst>
+  </p:cSld>
+  <p:clrMapOvr>
+    <a:masterClrMapping/>
+  </p:clrMapOvr>
+</p:sld>
+</file>
+
+<file path=ppt/slides/slide4.xml><?xml version="1.0" encoding="utf-8"?>
+<p:sld xmlns:a="http://schemas.openxmlformats.org/drawingml/2006/main" xmlns:r="http://schemas.openxmlformats.org/officeDocument/2006/relationships" xmlns:p="http://schemas.openxmlformats.org/presentationml/2006/main">
+  <p:cSld>
+    <p:spTree>
+      <p:nvGrpSpPr>
+        <p:cNvPr id="1" name="">
+          <a:extLst>
+            <a:ext uri="{FF2B5EF4-FFF2-40B4-BE49-F238E27FC236}">
+              <a16:creationId xmlns:a16="http://schemas.microsoft.com/office/drawing/2014/main" id="{AB19A7A9-8317-74C5-2935-74875BED017E}"/>
+            </a:ext>
+          </a:extLst>
+        </p:cNvPr>
+        <p:cNvGrpSpPr/>
+        <p:nvPr/>
+      </p:nvGrpSpPr>
+      <p:grpSpPr>
+        <a:xfrm>
+          <a:off x="0" y="0"/>
+          <a:ext cx="0" cy="0"/>
+          <a:chOff x="0" y="0"/>
+          <a:chExt cx="0" cy="0"/>
+        </a:xfrm>
+      </p:grpSpPr>
+      <p:sp>
+        <p:nvSpPr>
+          <p:cNvPr id="7" name="Title 6">
+            <a:extLst>
+              <a:ext uri="{FF2B5EF4-FFF2-40B4-BE49-F238E27FC236}">
+                <a16:creationId xmlns:a16="http://schemas.microsoft.com/office/drawing/2014/main" id="{C10BFB91-FED0-D611-213E-1CE17DE9425D}"/>
+              </a:ext>
+            </a:extLst>
+          </p:cNvPr>
+          <p:cNvSpPr>
+            <a:spLocks noGrp="1"/>
+          </p:cNvSpPr>
+          <p:nvPr>
+            <p:ph type="ctrTitle"/>
+          </p:nvPr>
+        </p:nvSpPr>
+        <p:spPr>
+          <a:xfrm>
+            <a:off x="165100" y="169863"/>
+            <a:ext cx="5048250" cy="941387"/>
+          </a:xfrm>
+        </p:spPr>
+        <p:txBody>
+          <a:bodyPr vert="horz" lIns="91440" tIns="45720" rIns="91440" bIns="45720" rtlCol="0" anchor="b">
+            <a:noAutofit/>
+          </a:bodyPr>
+          <a:lstStyle/>
+          <a:p>
+            <a:pPr algn="l"/>
+            <a:r>
+              <a:rPr lang="en-US" sz="3200" u="sng" dirty="0">
+                <a:latin typeface="Segoe UI Black" panose="020B0A02040204020203" pitchFamily="34" charset="0"/>
+                <a:ea typeface="Segoe UI Black" panose="020B0A02040204020203" pitchFamily="34" charset="0"/>
+              </a:rPr>
+              <a:t>The Bottleneck</a:t>
+            </a:r>
+            <a:endParaRPr lang="LID4096" sz="3200" u="sng" dirty="0">
+              <a:latin typeface="Segoe UI Black" panose="020B0A02040204020203" pitchFamily="34" charset="0"/>
+              <a:ea typeface="Segoe UI Black" panose="020B0A02040204020203" pitchFamily="34" charset="0"/>
+            </a:endParaRPr>
+          </a:p>
+        </p:txBody>
+      </p:sp>
+      <mc:AlternateContent xmlns:mc="http://schemas.openxmlformats.org/markup-compatibility/2006">
+        <mc:Choice xmlns:a14="http://schemas.microsoft.com/office/drawing/2010/main" Requires="a14">
+          <p:sp>
+            <p:nvSpPr>
+              <p:cNvPr id="12" name="Subtitle 2">
+                <a:extLst>
+                  <a:ext uri="{FF2B5EF4-FFF2-40B4-BE49-F238E27FC236}">
+                    <a16:creationId xmlns:a16="http://schemas.microsoft.com/office/drawing/2014/main" id="{A7569F0F-F547-146D-68F5-9B9367B99BC6}"/>
+                  </a:ext>
+                </a:extLst>
+              </p:cNvPr>
+              <p:cNvSpPr>
+                <a:spLocks noGrp="1"/>
+              </p:cNvSpPr>
+              <p:nvPr>
+                <p:ph type="subTitle" idx="1"/>
+              </p:nvPr>
+            </p:nvSpPr>
+            <p:spPr>
+              <a:xfrm>
+                <a:off x="165100" y="1181100"/>
+                <a:ext cx="11817350" cy="3810000"/>
+              </a:xfrm>
+            </p:spPr>
+            <p:txBody>
+              <a:bodyPr>
+                <a:normAutofit/>
+              </a:bodyPr>
+              <a:lstStyle/>
+              <a:p>
+                <a:pPr marL="285750" indent="-285750" algn="l">
+                  <a:buFont typeface="Arial" panose="020B0604020202020204" pitchFamily="34" charset="0"/>
+                  <a:buChar char="•"/>
+                </a:pPr>
+                <a:r>
+                  <a:rPr lang="en-US" sz="1800" dirty="0">
+                    <a:latin typeface="Segoe UI" panose="020B0502040204020203" pitchFamily="34" charset="0"/>
+                    <a:cs typeface="Segoe UI" panose="020B0502040204020203" pitchFamily="34" charset="0"/>
+                  </a:rPr>
+                  <a:t>ESP-32 max BAUD rate thru the USB is </a:t>
+                </a:r>
+                <a14:m>
+                  <m:oMath xmlns:m="http://schemas.openxmlformats.org/officeDocument/2006/math">
+                    <m:r>
+                      <a:rPr lang="en-US" sz="1800" b="0" i="1" smtClean="0">
+                        <a:latin typeface="Cambria Math" panose="02040503050406030204" pitchFamily="18" charset="0"/>
+                      </a:rPr>
+                      <m:t>921600</m:t>
+                    </m:r>
+                    <m:r>
+                      <a:rPr lang="en-US" sz="1800" b="0" i="0" smtClean="0">
+                        <a:latin typeface="Cambria Math" panose="02040503050406030204" pitchFamily="18" charset="0"/>
+                      </a:rPr>
+                      <m:t> </m:t>
+                    </m:r>
+                    <m:r>
+                      <m:rPr>
+                        <m:sty m:val="p"/>
+                      </m:rPr>
+                      <a:rPr lang="en-US" sz="1800" b="0" i="0" smtClean="0">
+                        <a:latin typeface="Cambria Math" panose="02040503050406030204" pitchFamily="18" charset="0"/>
+                      </a:rPr>
+                      <m:t>bps</m:t>
+                    </m:r>
+                    <m:r>
+                      <a:rPr lang="en-US" sz="1800" b="0" i="0" smtClean="0">
+                        <a:latin typeface="Cambria Math" panose="02040503050406030204" pitchFamily="18" charset="0"/>
+                      </a:rPr>
+                      <m:t>.</m:t>
+                    </m:r>
+                  </m:oMath>
+                </a14:m>
+                <a:r>
+                  <a:rPr lang="en-US" sz="1800" dirty="0">
+                    <a:latin typeface="Segoe UI" panose="020B0502040204020203" pitchFamily="34" charset="0"/>
+                    <a:cs typeface="Segoe UI" panose="020B0502040204020203" pitchFamily="34" charset="0"/>
+                  </a:rPr>
+                  <a:t> </a:t>
+                </a:r>
+                <a:br>
+                  <a:rPr lang="en-US" sz="1800" dirty="0">
+                    <a:latin typeface="Segoe UI" panose="020B0502040204020203" pitchFamily="34" charset="0"/>
+                    <a:cs typeface="Segoe UI" panose="020B0502040204020203" pitchFamily="34" charset="0"/>
+                  </a:rPr>
+                </a:br>
+                <a:r>
+                  <a:rPr lang="en-US" sz="1800" dirty="0">
+                    <a:latin typeface="Segoe UI" panose="020B0502040204020203" pitchFamily="34" charset="0"/>
+                    <a:cs typeface="Segoe UI" panose="020B0502040204020203" pitchFamily="34" charset="0"/>
+                  </a:rPr>
+                  <a:t>To send a byte of data, the chip also a byte start and byte stop bit so 10 bits in total, </a:t>
+                </a:r>
+                <a:br>
+                  <a:rPr lang="en-US" sz="1800" dirty="0">
+                    <a:latin typeface="Segoe UI" panose="020B0502040204020203" pitchFamily="34" charset="0"/>
+                    <a:cs typeface="Segoe UI" panose="020B0502040204020203" pitchFamily="34" charset="0"/>
+                  </a:rPr>
+                </a:br>
+                <a:r>
+                  <a:rPr lang="en-US" sz="1800" dirty="0">
+                    <a:latin typeface="Segoe UI" panose="020B0502040204020203" pitchFamily="34" charset="0"/>
+                    <a:cs typeface="Segoe UI" panose="020B0502040204020203" pitchFamily="34" charset="0"/>
+                  </a:rPr>
+                  <a:t>meaning we send data at a rate of </a:t>
+                </a:r>
+                <a14:m>
+                  <m:oMath xmlns:m="http://schemas.openxmlformats.org/officeDocument/2006/math">
+                    <m:r>
+                      <a:rPr lang="en-US" sz="1800" b="1" i="1" smtClean="0">
+                        <a:latin typeface="Cambria Math" panose="02040503050406030204" pitchFamily="18" charset="0"/>
+                      </a:rPr>
+                      <m:t>𝟗𝟐𝟏𝟔𝟎</m:t>
+                    </m:r>
+                    <m:f>
+                      <m:fPr>
+                        <m:ctrlPr>
+                          <a:rPr lang="en-US" sz="1800" b="1" i="1" smtClean="0">
+                            <a:latin typeface="Cambria Math" panose="02040503050406030204" pitchFamily="18" charset="0"/>
+                          </a:rPr>
+                        </m:ctrlPr>
+                      </m:fPr>
+                      <m:num>
+                        <m:r>
+                          <a:rPr lang="en-US" sz="1800" b="1" i="1" smtClean="0">
+                            <a:latin typeface="Cambria Math" panose="02040503050406030204" pitchFamily="18" charset="0"/>
+                          </a:rPr>
+                          <m:t>𝒃𝒚𝒕𝒆𝒔</m:t>
+                        </m:r>
+                      </m:num>
+                      <m:den>
+                        <m:r>
+                          <a:rPr lang="en-US" sz="1800" b="1" i="1" smtClean="0">
+                            <a:latin typeface="Cambria Math" panose="02040503050406030204" pitchFamily="18" charset="0"/>
+                          </a:rPr>
+                          <m:t>𝒔𝒆𝒄𝒐𝒏𝒅</m:t>
+                        </m:r>
+                      </m:den>
+                    </m:f>
+                    <m:r>
+                      <a:rPr lang="en-US" sz="1800" b="1" i="1" smtClean="0">
+                        <a:latin typeface="Cambria Math" panose="02040503050406030204" pitchFamily="18" charset="0"/>
+                      </a:rPr>
+                      <m:t>≈</m:t>
+                    </m:r>
+                    <m:r>
+                      <a:rPr lang="en-US" sz="1800" b="1" i="1" smtClean="0">
+                        <a:latin typeface="Cambria Math" panose="02040503050406030204" pitchFamily="18" charset="0"/>
+                      </a:rPr>
+                      <m:t>𝟗𝟐</m:t>
+                    </m:r>
+                    <m:r>
+                      <a:rPr lang="en-US" sz="1800" b="1" i="1" smtClean="0">
+                        <a:latin typeface="Cambria Math" panose="02040503050406030204" pitchFamily="18" charset="0"/>
+                      </a:rPr>
+                      <m:t>𝑲𝑩𝒑𝒔</m:t>
+                    </m:r>
+                    <m:r>
+                      <a:rPr lang="en-US" sz="1800" b="0" i="1" smtClean="0">
+                        <a:latin typeface="Cambria Math" panose="02040503050406030204" pitchFamily="18" charset="0"/>
+                      </a:rPr>
+                      <m:t>.</m:t>
+                    </m:r>
+                  </m:oMath>
+                </a14:m>
+                <a:r>
+                  <a:rPr lang="en-US" sz="1800" b="0" dirty="0">
+                    <a:latin typeface="Segoe UI" panose="020B0502040204020203" pitchFamily="34" charset="0"/>
+                    <a:cs typeface="Segoe UI" panose="020B0502040204020203" pitchFamily="34" charset="0"/>
+                  </a:rPr>
+                  <a:t> </a:t>
+                </a:r>
+              </a:p>
+              <a:p>
+                <a:pPr marL="285750" indent="-285750" algn="l">
+                  <a:buFont typeface="Arial" panose="020B0604020202020204" pitchFamily="34" charset="0"/>
+                  <a:buChar char="•"/>
+                </a:pPr>
+                <a:r>
+                  <a:rPr lang="en-US" sz="1800" dirty="0">
+                    <a:latin typeface="Segoe UI" panose="020B0502040204020203" pitchFamily="34" charset="0"/>
+                    <a:cs typeface="Segoe UI" panose="020B0502040204020203" pitchFamily="34" charset="0"/>
+                  </a:rPr>
+                  <a:t>Data is sent to the plotter is using strings with size of 16-20 bytes. </a:t>
+                </a:r>
+              </a:p>
+              <a:p>
+                <a:pPr marL="285750" indent="-285750" algn="l">
+                  <a:buFont typeface="Arial" panose="020B0604020202020204" pitchFamily="34" charset="0"/>
+                  <a:buChar char="•"/>
+                </a:pPr>
+                <a:r>
+                  <a:rPr lang="en-US" sz="1800" dirty="0">
+                    <a:latin typeface="Segoe UI" panose="020B0502040204020203" pitchFamily="34" charset="0"/>
+                    <a:cs typeface="Segoe UI" panose="020B0502040204020203" pitchFamily="34" charset="0"/>
+                  </a:rPr>
+                  <a:t>Worst case – The size of all 256 relevant bins will </a:t>
+                </a:r>
+                <a14:m>
+                  <m:oMath xmlns:m="http://schemas.openxmlformats.org/officeDocument/2006/math">
+                    <m:r>
+                      <a:rPr lang="en-US" sz="1800" b="0" i="1" smtClean="0">
+                        <a:latin typeface="Cambria Math" panose="02040503050406030204" pitchFamily="18" charset="0"/>
+                      </a:rPr>
+                      <m:t>≈5.1 </m:t>
+                    </m:r>
+                    <m:r>
+                      <a:rPr lang="en-US" sz="1800" b="0" i="1" smtClean="0">
+                        <a:latin typeface="Cambria Math" panose="02040503050406030204" pitchFamily="18" charset="0"/>
+                      </a:rPr>
+                      <m:t>𝐾𝐵</m:t>
+                    </m:r>
+                  </m:oMath>
+                </a14:m>
+                <a:endParaRPr lang="en-US" sz="1800" b="0" dirty="0">
+                  <a:latin typeface="Segoe UI" panose="020B0502040204020203" pitchFamily="34" charset="0"/>
+                  <a:cs typeface="Segoe UI" panose="020B0502040204020203" pitchFamily="34" charset="0"/>
+                </a:endParaRPr>
+              </a:p>
+              <a:p>
+                <a:pPr marL="285750" indent="-285750" algn="l">
+                  <a:buFont typeface="Arial" panose="020B0604020202020204" pitchFamily="34" charset="0"/>
+                  <a:buChar char="•"/>
+                </a:pPr>
+                <a:r>
+                  <a:rPr lang="en-US" sz="1800" b="0" dirty="0">
+                    <a:latin typeface="Segoe UI" panose="020B0502040204020203" pitchFamily="34" charset="0"/>
+                    <a:cs typeface="Segoe UI" panose="020B0502040204020203" pitchFamily="34" charset="0"/>
+                  </a:rPr>
+                  <a:t>At </a:t>
+                </a:r>
+                <a14:m>
+                  <m:oMath xmlns:m="http://schemas.openxmlformats.org/officeDocument/2006/math">
+                    <m:r>
+                      <a:rPr lang="en-US" sz="1800" b="0" i="1" smtClean="0">
+                        <a:latin typeface="Cambria Math" panose="02040503050406030204" pitchFamily="18" charset="0"/>
+                      </a:rPr>
+                      <m:t>92 </m:t>
+                    </m:r>
+                    <m:r>
+                      <a:rPr lang="en-US" sz="1800" b="0" i="1" smtClean="0">
+                        <a:latin typeface="Cambria Math" panose="02040503050406030204" pitchFamily="18" charset="0"/>
+                      </a:rPr>
+                      <m:t>𝐾𝐵𝑝𝑠</m:t>
+                    </m:r>
+                  </m:oMath>
+                </a14:m>
+                <a:r>
+                  <a:rPr lang="en-US" sz="1800" b="0" dirty="0">
+                    <a:latin typeface="Segoe UI" panose="020B0502040204020203" pitchFamily="34" charset="0"/>
+                    <a:cs typeface="Segoe UI" panose="020B0502040204020203" pitchFamily="34" charset="0"/>
+                  </a:rPr>
+                  <a:t> sending all the data will take  </a:t>
+                </a:r>
+                <a14:m>
+                  <m:oMath xmlns:m="http://schemas.openxmlformats.org/officeDocument/2006/math">
+                    <m:f>
+                      <m:fPr>
+                        <m:ctrlPr>
+                          <a:rPr lang="en-US" sz="1800" b="0" i="0" smtClean="0">
+                            <a:latin typeface="Cambria Math" panose="02040503050406030204" pitchFamily="18" charset="0"/>
+                          </a:rPr>
+                        </m:ctrlPr>
+                      </m:fPr>
+                      <m:num>
+                        <m:r>
+                          <a:rPr lang="en-US" sz="1800">
+                            <a:latin typeface="Cambria Math" panose="02040503050406030204" pitchFamily="18" charset="0"/>
+                          </a:rPr>
+                          <m:t>5</m:t>
+                        </m:r>
+                        <m:r>
+                          <a:rPr lang="en-US" sz="1800" b="0" i="0" smtClean="0">
+                            <a:latin typeface="Cambria Math" panose="02040503050406030204" pitchFamily="18" charset="0"/>
+                          </a:rPr>
+                          <m:t>.1 </m:t>
+                        </m:r>
+                        <m:r>
+                          <m:rPr>
+                            <m:sty m:val="p"/>
+                          </m:rPr>
+                          <a:rPr lang="en-US" sz="1800" b="0" i="0" smtClean="0">
+                            <a:latin typeface="Cambria Math" panose="02040503050406030204" pitchFamily="18" charset="0"/>
+                          </a:rPr>
+                          <m:t>KB</m:t>
+                        </m:r>
+                      </m:num>
+                      <m:den>
+                        <m:r>
+                          <a:rPr lang="en-US" sz="1800" b="0" i="1" smtClean="0">
+                            <a:latin typeface="Cambria Math" panose="02040503050406030204" pitchFamily="18" charset="0"/>
+                          </a:rPr>
+                          <m:t>92 </m:t>
+                        </m:r>
+                        <m:r>
+                          <a:rPr lang="en-US" sz="1800" b="0" i="1" smtClean="0">
+                            <a:latin typeface="Cambria Math" panose="02040503050406030204" pitchFamily="18" charset="0"/>
+                          </a:rPr>
+                          <m:t>𝐾𝐵𝑝𝑠</m:t>
+                        </m:r>
+                      </m:den>
+                    </m:f>
+                    <m:r>
+                      <a:rPr lang="en-US" sz="1800" b="0" i="1" smtClean="0">
+                        <a:latin typeface="Cambria Math" panose="02040503050406030204" pitchFamily="18" charset="0"/>
+                      </a:rPr>
+                      <m:t> = </m:t>
+                    </m:r>
+                    <m:r>
+                      <a:rPr lang="en-US" sz="1800" b="0" i="1" smtClean="0">
+                        <a:latin typeface="Cambria Math" panose="02040503050406030204" pitchFamily="18" charset="0"/>
+                      </a:rPr>
+                      <m:t>55 </m:t>
+                    </m:r>
+                    <m:r>
+                      <a:rPr lang="en-US" sz="1800" b="0" i="1" smtClean="0">
+                        <a:latin typeface="Cambria Math" panose="02040503050406030204" pitchFamily="18" charset="0"/>
+                      </a:rPr>
+                      <m:t>𝑚𝑠</m:t>
+                    </m:r>
+                    <m:r>
+                      <a:rPr lang="en-US" sz="1800" b="0" i="0" smtClean="0">
+                        <a:latin typeface="Cambria Math" panose="02040503050406030204" pitchFamily="18" charset="0"/>
+                      </a:rPr>
+                      <m:t>&gt;</m:t>
+                    </m:r>
+                    <m:r>
+                      <a:rPr lang="en-US" sz="1800" b="0" i="1" dirty="0" smtClean="0">
+                        <a:latin typeface="Cambria Math" panose="02040503050406030204" pitchFamily="18" charset="0"/>
+                      </a:rPr>
+                      <m:t>51.2 </m:t>
+                    </m:r>
+                    <m:r>
+                      <a:rPr lang="en-US" sz="1800" b="0" i="1" dirty="0" smtClean="0">
+                        <a:latin typeface="Cambria Math" panose="02040503050406030204" pitchFamily="18" charset="0"/>
+                      </a:rPr>
+                      <m:t>𝑚𝑠</m:t>
+                    </m:r>
+                    <m:r>
+                      <a:rPr lang="en-US" sz="1800" b="0" i="1" dirty="0" smtClean="0">
+                        <a:latin typeface="Cambria Math" panose="02040503050406030204" pitchFamily="18" charset="0"/>
+                      </a:rPr>
+                      <m:t> →</m:t>
+                    </m:r>
+                  </m:oMath>
+                </a14:m>
+                <a:r>
+                  <a:rPr lang="en-US" sz="1800" b="0" dirty="0">
+                    <a:latin typeface="Segoe UI" panose="020B0502040204020203" pitchFamily="34" charset="0"/>
+                    <a:cs typeface="Segoe UI" panose="020B0502040204020203" pitchFamily="34" charset="0"/>
+                  </a:rPr>
+                  <a:t> Overflow.</a:t>
+                </a:r>
+              </a:p>
+              <a:p>
+                <a:pPr marL="285750" indent="-285750" algn="l">
+                  <a:buFont typeface="Arial" panose="020B0604020202020204" pitchFamily="34" charset="0"/>
+                  <a:buChar char="•"/>
+                </a:pPr>
+                <a:r>
+                  <a:rPr lang="en-US" sz="1800" dirty="0">
+                    <a:latin typeface="Segoe UI" panose="020B0502040204020203" pitchFamily="34" charset="0"/>
+                    <a:cs typeface="Segoe UI" panose="020B0502040204020203" pitchFamily="34" charset="0"/>
+                  </a:rPr>
+                  <a:t>Solution – Sending only the first </a:t>
+                </a:r>
+                <a:r>
+                  <a:rPr lang="en-US" sz="1800" b="1" dirty="0">
+                    <a:latin typeface="Segoe UI" panose="020B0502040204020203" pitchFamily="34" charset="0"/>
+                    <a:cs typeface="Segoe UI" panose="020B0502040204020203" pitchFamily="34" charset="0"/>
+                  </a:rPr>
+                  <a:t>154 bins </a:t>
+                </a:r>
+                <a:r>
+                  <a:rPr lang="en-US" sz="1800" dirty="0">
+                    <a:latin typeface="Segoe UI" panose="020B0502040204020203" pitchFamily="34" charset="0"/>
+                    <a:cs typeface="Segoe UI" panose="020B0502040204020203" pitchFamily="34" charset="0"/>
+                  </a:rPr>
+                  <a:t>(</a:t>
+                </a:r>
+                <a14:m>
+                  <m:oMath xmlns:m="http://schemas.openxmlformats.org/officeDocument/2006/math">
+                    <m:r>
+                      <a:rPr lang="en-US" sz="1800" i="1" dirty="0" smtClean="0">
+                        <a:latin typeface="Cambria Math" panose="02040503050406030204" pitchFamily="18" charset="0"/>
+                      </a:rPr>
+                      <m:t>2.5</m:t>
+                    </m:r>
+                    <m:r>
+                      <a:rPr lang="en-US" sz="1800" b="0" i="1" dirty="0" smtClean="0">
+                        <a:latin typeface="Cambria Math" panose="02040503050406030204" pitchFamily="18" charset="0"/>
+                      </a:rPr>
+                      <m:t>5</m:t>
+                    </m:r>
+                    <m:r>
+                      <a:rPr lang="en-US" sz="1800" i="1" dirty="0" smtClean="0">
+                        <a:latin typeface="Cambria Math" panose="02040503050406030204" pitchFamily="18" charset="0"/>
+                      </a:rPr>
+                      <m:t> </m:t>
+                    </m:r>
+                    <m:r>
+                      <a:rPr lang="en-US" sz="1800" i="1" dirty="0" smtClean="0">
+                        <a:latin typeface="Cambria Math" panose="02040503050406030204" pitchFamily="18" charset="0"/>
+                      </a:rPr>
+                      <m:t>𝐾𝐵</m:t>
+                    </m:r>
+                  </m:oMath>
+                </a14:m>
+                <a:r>
+                  <a:rPr lang="en-US" sz="1800" dirty="0">
+                    <a:latin typeface="Segoe UI" panose="020B0502040204020203" pitchFamily="34" charset="0"/>
+                    <a:cs typeface="Segoe UI" panose="020B0502040204020203" pitchFamily="34" charset="0"/>
+                  </a:rPr>
+                  <a:t>) to the plotter (representing </a:t>
+                </a:r>
+                <a14:m>
+                  <m:oMath xmlns:m="http://schemas.openxmlformats.org/officeDocument/2006/math">
+                    <m:r>
+                      <a:rPr lang="en-US" sz="1800" i="1" dirty="0" smtClean="0">
+                        <a:latin typeface="Cambria Math" panose="02040503050406030204" pitchFamily="18" charset="0"/>
+                      </a:rPr>
+                      <m:t>0−</m:t>
+                    </m:r>
+                    <m:r>
+                      <a:rPr lang="en-US" sz="1800" b="0" i="1" dirty="0" smtClean="0">
+                        <a:latin typeface="Cambria Math" panose="02040503050406030204" pitchFamily="18" charset="0"/>
+                      </a:rPr>
+                      <m:t>3</m:t>
+                    </m:r>
+                    <m:r>
+                      <a:rPr lang="en-US" sz="1800" i="1" dirty="0" smtClean="0">
+                        <a:latin typeface="Cambria Math" panose="02040503050406030204" pitchFamily="18" charset="0"/>
+                      </a:rPr>
+                      <m:t>𝐾h𝑧</m:t>
+                    </m:r>
+                  </m:oMath>
+                </a14:m>
+                <a:r>
+                  <a:rPr lang="en-US" sz="1800" dirty="0">
+                    <a:latin typeface="Segoe UI" panose="020B0502040204020203" pitchFamily="34" charset="0"/>
+                    <a:cs typeface="Segoe UI" panose="020B0502040204020203" pitchFamily="34" charset="0"/>
+                  </a:rPr>
+                  <a:t>). </a:t>
+                </a:r>
+                <a:br>
+                  <a:rPr lang="en-US" sz="1800" dirty="0">
+                    <a:latin typeface="Segoe UI" panose="020B0502040204020203" pitchFamily="34" charset="0"/>
+                    <a:cs typeface="Segoe UI" panose="020B0502040204020203" pitchFamily="34" charset="0"/>
+                  </a:rPr>
+                </a:br>
+                <a:r>
+                  <a:rPr lang="en-US" sz="1800" dirty="0">
+                    <a:latin typeface="Segoe UI" panose="020B0502040204020203" pitchFamily="34" charset="0"/>
+                    <a:cs typeface="Segoe UI" panose="020B0502040204020203" pitchFamily="34" charset="0"/>
+                  </a:rPr>
+                  <a:t>In this case, sending the data will take </a:t>
+                </a:r>
+                <a14:m>
+                  <m:oMath xmlns:m="http://schemas.openxmlformats.org/officeDocument/2006/math">
+                    <m:f>
+                      <m:fPr>
+                        <m:ctrlPr>
+                          <a:rPr lang="en-US" sz="1800" b="0" i="1" smtClean="0">
+                            <a:latin typeface="Cambria Math" panose="02040503050406030204" pitchFamily="18" charset="0"/>
+                          </a:rPr>
+                        </m:ctrlPr>
+                      </m:fPr>
+                      <m:num>
+                        <m:r>
+                          <a:rPr lang="en-US" sz="1800" b="0" i="1" smtClean="0">
+                            <a:latin typeface="Cambria Math" panose="02040503050406030204" pitchFamily="18" charset="0"/>
+                          </a:rPr>
+                          <m:t>3.08 </m:t>
+                        </m:r>
+                        <m:r>
+                          <a:rPr lang="en-US" sz="1800" b="0" i="1" smtClean="0">
+                            <a:latin typeface="Cambria Math" panose="02040503050406030204" pitchFamily="18" charset="0"/>
+                          </a:rPr>
+                          <m:t>𝐾𝐵</m:t>
+                        </m:r>
+                      </m:num>
+                      <m:den>
+                        <m:r>
+                          <a:rPr lang="en-US" sz="1800" b="0" i="1" smtClean="0">
+                            <a:latin typeface="Cambria Math" panose="02040503050406030204" pitchFamily="18" charset="0"/>
+                          </a:rPr>
+                          <m:t>92 </m:t>
+                        </m:r>
+                        <m:r>
+                          <a:rPr lang="en-US" sz="1800" b="0" i="1" smtClean="0">
+                            <a:latin typeface="Cambria Math" panose="02040503050406030204" pitchFamily="18" charset="0"/>
+                          </a:rPr>
+                          <m:t>𝐾𝐵𝑝𝑠</m:t>
+                        </m:r>
+                      </m:den>
+                    </m:f>
+                    <m:r>
+                      <a:rPr lang="en-US" sz="1800" b="0" i="1" smtClean="0">
+                        <a:latin typeface="Cambria Math" panose="02040503050406030204" pitchFamily="18" charset="0"/>
+                      </a:rPr>
+                      <m:t>≈33.5 </m:t>
+                    </m:r>
+                    <m:r>
+                      <a:rPr lang="en-US" sz="1800" b="0" i="1" smtClean="0">
+                        <a:latin typeface="Cambria Math" panose="02040503050406030204" pitchFamily="18" charset="0"/>
+                      </a:rPr>
+                      <m:t>𝑚𝑠</m:t>
+                    </m:r>
+                  </m:oMath>
+                </a14:m>
+                <a:r>
+                  <a:rPr lang="en-US" sz="1800" dirty="0">
+                    <a:latin typeface="Segoe UI" panose="020B0502040204020203" pitchFamily="34" charset="0"/>
+                    <a:cs typeface="Segoe UI" panose="020B0502040204020203" pitchFamily="34" charset="0"/>
+                  </a:rPr>
+                  <a:t>.</a:t>
+                </a:r>
+              </a:p>
+              <a:p>
+                <a:pPr marL="285750" indent="-285750" algn="l">
+                  <a:buFont typeface="Arial" panose="020B0604020202020204" pitchFamily="34" charset="0"/>
+                  <a:buChar char="•"/>
+                </a:pPr>
+                <a:r>
+                  <a:rPr lang="en-US" sz="1800" b="1" dirty="0">
+                    <a:latin typeface="Segoe UI" panose="020B0502040204020203" pitchFamily="34" charset="0"/>
+                    <a:cs typeface="Segoe UI" panose="020B0502040204020203" pitchFamily="34" charset="0"/>
+                  </a:rPr>
+                  <a:t>Naive DFT Total time - </a:t>
+                </a:r>
+                <a14:m>
+                  <m:oMath xmlns:m="http://schemas.openxmlformats.org/officeDocument/2006/math">
+                    <m:r>
+                      <a:rPr lang="en-US" sz="1800" b="0" i="1" smtClean="0">
+                        <a:latin typeface="Cambria Math" panose="02040503050406030204" pitchFamily="18" charset="0"/>
+                        <a:cs typeface="Segoe UI" panose="020B0502040204020203" pitchFamily="34" charset="0"/>
+                      </a:rPr>
+                      <m:t>16+33.5=49.5</m:t>
+                    </m:r>
+                    <m:r>
+                      <a:rPr lang="en-US" sz="1800" b="0" i="1" smtClean="0">
+                        <a:latin typeface="Cambria Math" panose="02040503050406030204" pitchFamily="18" charset="0"/>
+                        <a:cs typeface="Segoe UI" panose="020B0502040204020203" pitchFamily="34" charset="0"/>
+                      </a:rPr>
+                      <m:t>𝑚𝑠</m:t>
+                    </m:r>
+                  </m:oMath>
+                </a14:m>
+                <a:r>
+                  <a:rPr lang="en-US" sz="1800" dirty="0">
+                    <a:latin typeface="Segoe UI" panose="020B0502040204020203" pitchFamily="34" charset="0"/>
+                    <a:cs typeface="Segoe UI" panose="020B0502040204020203" pitchFamily="34" charset="0"/>
+                  </a:rPr>
+                  <a:t> - very close to the </a:t>
+                </a:r>
+                <a14:m>
+                  <m:oMath xmlns:m="http://schemas.openxmlformats.org/officeDocument/2006/math">
+                    <m:r>
+                      <a:rPr lang="en-US" sz="1800" i="1" dirty="0" smtClean="0">
+                        <a:latin typeface="Cambria Math" panose="02040503050406030204" pitchFamily="18" charset="0"/>
+                        <a:cs typeface="Segoe UI" panose="020B0502040204020203" pitchFamily="34" charset="0"/>
+                      </a:rPr>
+                      <m:t>51.2</m:t>
+                    </m:r>
+                    <m:r>
+                      <a:rPr lang="en-US" sz="1800" b="0" i="1" dirty="0" smtClean="0">
+                        <a:latin typeface="Cambria Math" panose="02040503050406030204" pitchFamily="18" charset="0"/>
+                        <a:cs typeface="Segoe UI" panose="020B0502040204020203" pitchFamily="34" charset="0"/>
+                      </a:rPr>
+                      <m:t> </m:t>
+                    </m:r>
+                    <m:r>
+                      <a:rPr lang="en-US" sz="1800" b="0" i="1" dirty="0" smtClean="0">
+                        <a:latin typeface="Cambria Math" panose="02040503050406030204" pitchFamily="18" charset="0"/>
+                        <a:cs typeface="Segoe UI" panose="020B0502040204020203" pitchFamily="34" charset="0"/>
+                      </a:rPr>
+                      <m:t>𝑚𝑠</m:t>
+                    </m:r>
+                  </m:oMath>
+                </a14:m>
+                <a:r>
+                  <a:rPr lang="en-US" sz="1800" dirty="0">
+                    <a:latin typeface="Segoe UI" panose="020B0502040204020203" pitchFamily="34" charset="0"/>
+                    <a:cs typeface="Segoe UI" panose="020B0502040204020203" pitchFamily="34" charset="0"/>
+                  </a:rPr>
+                  <a:t> limit and not practical</a:t>
+                </a:r>
+              </a:p>
+              <a:p>
+                <a:pPr marL="285750" indent="-285750" algn="l">
+                  <a:buFont typeface="Arial" panose="020B0604020202020204" pitchFamily="34" charset="0"/>
+                  <a:buChar char="•"/>
+                </a:pPr>
+                <a:r>
+                  <a:rPr lang="en-US" sz="1800" b="1" dirty="0">
+                    <a:latin typeface="Segoe UI" panose="020B0502040204020203" pitchFamily="34" charset="0"/>
+                    <a:cs typeface="Segoe UI" panose="020B0502040204020203" pitchFamily="34" charset="0"/>
+                  </a:rPr>
+                  <a:t>FFT Total time - </a:t>
+                </a:r>
+                <a14:m>
+                  <m:oMath xmlns:m="http://schemas.openxmlformats.org/officeDocument/2006/math">
+                    <m:r>
+                      <a:rPr lang="en-US" sz="1800" i="1">
+                        <a:latin typeface="Cambria Math" panose="02040503050406030204" pitchFamily="18" charset="0"/>
+                      </a:rPr>
+                      <m:t>0.288</m:t>
+                    </m:r>
+                    <m:r>
+                      <a:rPr lang="en-US" sz="1800" b="0" i="1" smtClean="0">
+                        <a:latin typeface="Cambria Math" panose="02040503050406030204" pitchFamily="18" charset="0"/>
+                      </a:rPr>
+                      <m:t>+33.5=33.788</m:t>
+                    </m:r>
+                    <m:r>
+                      <a:rPr lang="en-US" sz="1800" i="1">
+                        <a:latin typeface="Cambria Math" panose="02040503050406030204" pitchFamily="18" charset="0"/>
+                      </a:rPr>
+                      <m:t> </m:t>
+                    </m:r>
+                    <m:r>
+                      <a:rPr lang="en-US" sz="1800" i="1">
+                        <a:latin typeface="Cambria Math" panose="02040503050406030204" pitchFamily="18" charset="0"/>
+                      </a:rPr>
+                      <m:t>𝑚𝑠</m:t>
+                    </m:r>
+                  </m:oMath>
+                </a14:m>
+                <a:r>
+                  <a:rPr lang="en-US" sz="1800" b="1" dirty="0">
+                    <a:latin typeface="Segoe UI" panose="020B0502040204020203" pitchFamily="34" charset="0"/>
+                    <a:cs typeface="Segoe UI" panose="020B0502040204020203" pitchFamily="34" charset="0"/>
+                  </a:rPr>
+                  <a:t> -</a:t>
+                </a:r>
+                <a:r>
+                  <a:rPr lang="en-US" sz="1800" dirty="0">
+                    <a:latin typeface="Segoe UI" panose="020B0502040204020203" pitchFamily="34" charset="0"/>
+                    <a:cs typeface="Segoe UI" panose="020B0502040204020203" pitchFamily="34" charset="0"/>
+                  </a:rPr>
+                  <a:t> Far away from the limit!</a:t>
+                </a:r>
+              </a:p>
+            </p:txBody>
+          </p:sp>
+        </mc:Choice>
+        <mc:Fallback>
+          <p:sp>
+            <p:nvSpPr>
+              <p:cNvPr id="12" name="Subtitle 2">
+                <a:extLst>
+                  <a:ext uri="{FF2B5EF4-FFF2-40B4-BE49-F238E27FC236}">
+                    <a16:creationId xmlns:a16="http://schemas.microsoft.com/office/drawing/2014/main" id="{A7569F0F-F547-146D-68F5-9B9367B99BC6}"/>
+                  </a:ext>
+                </a:extLst>
+              </p:cNvPr>
+              <p:cNvSpPr>
+                <a:spLocks noGrp="1" noRot="1" noChangeAspect="1" noMove="1" noResize="1" noEditPoints="1" noAdjustHandles="1" noChangeArrowheads="1" noChangeShapeType="1" noTextEdit="1"/>
+              </p:cNvSpPr>
+              <p:nvPr>
+                <p:ph type="subTitle" idx="1"/>
+              </p:nvPr>
+            </p:nvSpPr>
+            <p:spPr>
+              <a:xfrm>
+                <a:off x="165100" y="1181100"/>
+                <a:ext cx="11817350" cy="3810000"/>
+              </a:xfrm>
+              <a:blipFill>
+                <a:blip r:embed="rId2"/>
+                <a:stretch>
+                  <a:fillRect l="-309" t="-1600"/>
+                </a:stretch>
+              </a:blipFill>
+            </p:spPr>
+            <p:txBody>
+              <a:bodyPr/>
+              <a:lstStyle/>
+              <a:p>
+                <a:r>
+                  <a:rPr lang="LID4096">
+                    <a:noFill/>
+                  </a:rPr>
+                  <a:t> </a:t>
+                </a:r>
+              </a:p>
+            </p:txBody>
+          </p:sp>
+        </mc:Fallback>
+      </mc:AlternateContent>
+    </p:spTree>
+    <p:extLst>
+      <p:ext uri="{BB962C8B-B14F-4D97-AF65-F5344CB8AC3E}">
+        <p14:creationId xmlns:p14="http://schemas.microsoft.com/office/powerpoint/2010/main" val="299412291"/>
       </p:ext>
     </p:extLst>
   </p:cSld>

</xml_diff>